<commit_message>
docs: update user walkthrough presentation with step-by-step red circle click callouts
</commit_message>
<xml_diff>
--- a/AutoExplain_User_Journey_Walkthrough.pptx
+++ b/AutoExplain_User_Journey_Walkthrough.pptx
@@ -13,6 +13,11 @@
     <p:sldId id="261" r:id="rId12"/>
     <p:sldId id="262" r:id="rId13"/>
     <p:sldId id="263" r:id="rId14"/>
+    <p:sldId id="264" r:id="rId15"/>
+    <p:sldId id="265" r:id="rId16"/>
+    <p:sldId id="266" r:id="rId17"/>
+    <p:sldId id="267" r:id="rId18"/>
+    <p:sldId id="268" r:id="rId19"/>
   </p:sldIdLst>
   <p:sldSz cx="12191695" cy="6858000" type="screen4x3"/>
   <p:notesSz cx="6858000" cy="9144000"/>
@@ -3193,18 +3198,18 @@
         </p:nvSpPr>
         <p:spPr>
           <a:xfrm>
-            <a:off x="1645920" y="1554480"/>
-            <a:ext cx="2926080" cy="365760"/>
+            <a:off x="1645920" y="1463040"/>
+            <a:ext cx="3474720" cy="365760"/>
           </a:xfrm>
           <a:prstGeom prst="roundRect">
             <a:avLst/>
           </a:prstGeom>
           <a:solidFill>
-            <a:srgbClr val="ECFDF5"/>
+            <a:srgbClr val="FEF2F2"/>
           </a:solidFill>
           <a:ln w="12700">
             <a:solidFill>
-              <a:srgbClr val="10B981"/>
+              <a:srgbClr val="EF4444"/>
             </a:solidFill>
           </a:ln>
         </p:spPr>
@@ -3229,13 +3234,13 @@
             <a:pPr algn="ctr">
               <a:defRPr sz="1000" b="1">
                 <a:solidFill>
-                  <a:srgbClr val="047857"/>
-                </a:solidFill>
-                <a:latin typeface="Arial"/>
-              </a:defRPr>
-            </a:pPr>
-            <a:r>
-              <a:t>MECHANISTIC XAI · V0.1 ROADMAP</a:t>
+                  <a:srgbClr val="EF4444"/>
+                </a:solidFill>
+                <a:latin typeface="Arial"/>
+              </a:defRPr>
+            </a:pPr>
+            <a:r>
+              <a:t>🔴 USER ACTIONS WITH RED CIRCLE CALLOUTS</a:t>
             </a:r>
           </a:p>
         </p:txBody>
@@ -3248,7 +3253,7 @@
         </p:nvSpPr>
         <p:spPr>
           <a:xfrm>
-            <a:off x="1645920" y="2103120"/>
+            <a:off x="1645920" y="2011680"/>
             <a:ext cx="8869680" cy="1097280"/>
           </a:xfrm>
           <a:prstGeom prst="rect">
@@ -3284,7 +3289,7 @@
         </p:nvSpPr>
         <p:spPr>
           <a:xfrm>
-            <a:off x="1645920" y="3108960"/>
+            <a:off x="1645920" y="3017520"/>
             <a:ext cx="8869680" cy="731520"/>
           </a:xfrm>
           <a:prstGeom prst="rect">
@@ -3299,7 +3304,7 @@
           <a:lstStyle/>
           <a:p>
             <a:pPr>
-              <a:defRPr sz="1800">
+              <a:defRPr sz="1700">
                 <a:solidFill>
                   <a:srgbClr val="4B5563"/>
                 </a:solidFill>
@@ -3307,7 +3312,7 @@
               </a:defRPr>
             </a:pPr>
             <a:r>
-              <a:t>Walkthrough as User: From Zero-Setup Exploration to Cross-Model Causal Steering</a:t>
+              <a:t>Step-by-Step Feature Walkthrough: Every User Click Circled in Red</a:t>
             </a:r>
           </a:p>
         </p:txBody>
@@ -3362,12 +3367,12 @@
               </a:defRPr>
             </a:pPr>
             <a:r>
-              <a:t>Anti-Neuronpedia Simplicity</a:t>
-            </a:r>
-          </a:p>
-          <a:p>
-            <a:pPr>
-              <a:defRPr sz="1000">
+              <a:t>Visual Click Indicators</a:t>
+            </a:r>
+          </a:p>
+          <a:p>
+            <a:pPr>
+              <a:defRPr sz="950">
                 <a:solidFill>
                   <a:srgbClr val="4B5563"/>
                 </a:solidFill>
@@ -3375,7 +3380,7 @@
               </a:defRPr>
             </a:pPr>
             <a:r>
-              <a:t>Strictly 2 cards on screen: 1. Interpret and 2. Steer. Zero raw neuron math.</a:t>
+              <a:t>Each slide features a vibrant red circle callout directly over the element being clicked.</a:t>
             </a:r>
           </a:p>
         </p:txBody>
@@ -3430,12 +3435,12 @@
               </a:defRPr>
             </a:pPr>
             <a:r>
-              <a:t>Plain-English Readouts</a:t>
-            </a:r>
-          </a:p>
-          <a:p>
-            <a:pPr>
-              <a:defRPr sz="1000">
+              <a:t>Feature Discovery</a:t>
+            </a:r>
+          </a:p>
+          <a:p>
+            <a:pPr>
+              <a:defRPr sz="950">
                 <a:solidFill>
                   <a:srgbClr val="4B5563"/>
                 </a:solidFill>
@@ -3443,7 +3448,7 @@
               </a:defRPr>
             </a:pPr>
             <a:r>
-              <a:t>Click any word to read what internal concept fires in natural human language.</a:t>
+              <a:t>Follow a researcher journey from zero-setup token inspection to cross-model causal steering.</a:t>
             </a:r>
           </a:p>
         </p:txBody>
@@ -3498,12 +3503,12 @@
               </a:defRPr>
             </a:pPr>
             <a:r>
-              <a:t>Cross-Model Reusability</a:t>
-            </a:r>
-          </a:p>
-          <a:p>
-            <a:pPr>
-              <a:defRPr sz="1000">
+              <a:t>Strict 2-Card Simplicity</a:t>
+            </a:r>
+          </a:p>
+          <a:p>
+            <a:pPr>
+              <a:defRPr sz="950">
                 <a:solidFill>
                   <a:srgbClr val="4B5563"/>
                 </a:solidFill>
@@ -3511,7 +3516,1668 @@
               </a:defRPr>
             </a:pPr>
             <a:r>
-              <a:t>Save steering vectors as presets and test across .pt checkpoints seamlessly.</a:t>
+              <a:t>Card 1 (Interpret) and Card 2 (Steer) under the Unsloth Studio Light Theme (#F7FAF8).</a:t>
+            </a:r>
+          </a:p>
+        </p:txBody>
+      </p:sp>
+    </p:spTree>
+  </p:cSld>
+  <p:clrMapOvr>
+    <a:masterClrMapping/>
+  </p:clrMapOvr>
+</p:sld>
+</file>
+
+<file path=ppt/slides/slide10.xml><?xml version="1.0" encoding="utf-8"?>
+<p:sld xmlns:a="http://schemas.openxmlformats.org/drawingml/2006/main" xmlns:p="http://schemas.openxmlformats.org/presentationml/2006/main" xmlns:r="http://schemas.openxmlformats.org/officeDocument/2006/relationships">
+  <p:cSld>
+    <p:spTree>
+      <p:nvGrpSpPr>
+        <p:cNvPr id="1" name=""/>
+        <p:cNvGrpSpPr/>
+        <p:nvPr/>
+      </p:nvGrpSpPr>
+      <p:grpSpPr/>
+      <p:sp>
+        <p:nvSpPr>
+          <p:cNvPr id="2" name="Rectangle 1"/>
+          <p:cNvSpPr/>
+          <p:nvPr/>
+        </p:nvSpPr>
+        <p:spPr>
+          <a:xfrm>
+            <a:off x="0" y="0"/>
+            <a:ext cx="12191695" cy="6858000"/>
+          </a:xfrm>
+          <a:prstGeom prst="rect">
+            <a:avLst/>
+          </a:prstGeom>
+          <a:solidFill>
+            <a:srgbClr val="F7FAF8"/>
+          </a:solidFill>
+          <a:ln>
+            <a:solidFill>
+              <a:srgbClr val="F7FAF8"/>
+            </a:solidFill>
+          </a:ln>
+        </p:spPr>
+        <p:style>
+          <a:lnRef idx="1">
+            <a:schemeClr val="accent1"/>
+          </a:lnRef>
+          <a:fillRef idx="3">
+            <a:schemeClr val="accent1"/>
+          </a:fillRef>
+          <a:effectRef idx="2">
+            <a:schemeClr val="accent1"/>
+          </a:effectRef>
+          <a:fontRef idx="minor">
+            <a:schemeClr val="lt1"/>
+          </a:fontRef>
+        </p:style>
+        <p:txBody>
+          <a:bodyPr rtlCol="0" anchor="ctr"/>
+          <a:lstStyle/>
+          <a:p>
+            <a:pPr algn="ctr"/>
+          </a:p>
+        </p:txBody>
+      </p:sp>
+      <p:sp>
+        <p:nvSpPr>
+          <p:cNvPr id="3" name="TextBox 2"/>
+          <p:cNvSpPr txBox="1"/>
+          <p:nvPr/>
+        </p:nvSpPr>
+        <p:spPr>
+          <a:xfrm>
+            <a:off x="731520" y="365760"/>
+            <a:ext cx="6858000" cy="292608"/>
+          </a:xfrm>
+          <a:prstGeom prst="rect">
+            <a:avLst/>
+          </a:prstGeom>
+          <a:noFill/>
+        </p:spPr>
+        <p:txBody>
+          <a:bodyPr wrap="square" lIns="0" tIns="0" rIns="0" bIns="0">
+            <a:spAutoFit/>
+          </a:bodyPr>
+          <a:lstStyle/>
+          <a:p>
+            <a:pPr>
+              <a:defRPr sz="1000" b="1">
+                <a:solidFill>
+                  <a:srgbClr val="EF4444"/>
+                </a:solidFill>
+                <a:latin typeface="Arial"/>
+              </a:defRPr>
+            </a:pPr>
+            <a:r>
+              <a:t>STEP 8 OF 10 · RED CIRCLE: HEADER PILL 'GPT2-FINETUNED.PT'</a:t>
+            </a:r>
+          </a:p>
+        </p:txBody>
+      </p:sp>
+      <p:sp>
+        <p:nvSpPr>
+          <p:cNvPr id="4" name="TextBox 3"/>
+          <p:cNvSpPr txBox="1"/>
+          <p:nvPr/>
+        </p:nvSpPr>
+        <p:spPr>
+          <a:xfrm>
+            <a:off x="731520" y="658368"/>
+            <a:ext cx="10515600" cy="548640"/>
+          </a:xfrm>
+          <a:prstGeom prst="rect">
+            <a:avLst/>
+          </a:prstGeom>
+          <a:noFill/>
+        </p:spPr>
+        <p:txBody>
+          <a:bodyPr wrap="square" lIns="0" tIns="0" rIns="0" bIns="0">
+            <a:spAutoFit/>
+          </a:bodyPr>
+          <a:lstStyle/>
+          <a:p>
+            <a:pPr>
+              <a:defRPr sz="2100" b="1">
+                <a:solidFill>
+                  <a:srgbClr val="111815"/>
+                </a:solidFill>
+                <a:latin typeface="Arial"/>
+              </a:defRPr>
+            </a:pPr>
+            <a:r>
+              <a:t>Step 8: Cross-Model Checkpoint Switching</a:t>
+            </a:r>
+          </a:p>
+        </p:txBody>
+      </p:sp>
+      <p:sp>
+        <p:nvSpPr>
+          <p:cNvPr id="5" name="Rounded Rectangle 4"/>
+          <p:cNvSpPr/>
+          <p:nvPr/>
+        </p:nvSpPr>
+        <p:spPr>
+          <a:xfrm>
+            <a:off x="731520" y="1298448"/>
+            <a:ext cx="4114800" cy="5120640"/>
+          </a:xfrm>
+          <a:prstGeom prst="roundRect">
+            <a:avLst/>
+          </a:prstGeom>
+          <a:solidFill>
+            <a:srgbClr val="FFFFFF"/>
+          </a:solidFill>
+          <a:ln w="12700">
+            <a:solidFill>
+              <a:srgbClr val="E5E7EB"/>
+            </a:solidFill>
+          </a:ln>
+        </p:spPr>
+        <p:style>
+          <a:lnRef idx="1">
+            <a:schemeClr val="accent1"/>
+          </a:lnRef>
+          <a:fillRef idx="3">
+            <a:schemeClr val="accent1"/>
+          </a:fillRef>
+          <a:effectRef idx="2">
+            <a:schemeClr val="accent1"/>
+          </a:effectRef>
+          <a:fontRef idx="minor">
+            <a:schemeClr val="lt1"/>
+          </a:fontRef>
+        </p:style>
+        <p:txBody>
+          <a:bodyPr rtlCol="0" anchor="ctr" wrap="square" lIns="256032" rIns="256032" tIns="228600"/>
+          <a:lstStyle/>
+          <a:p>
+            <a:pPr algn="ctr">
+              <a:spcAft>
+                <a:spcPts val="800"/>
+              </a:spcAft>
+              <a:defRPr sz="1100" b="1">
+                <a:solidFill>
+                  <a:srgbClr val="EF4444"/>
+                </a:solidFill>
+                <a:latin typeface="Arial"/>
+              </a:defRPr>
+            </a:pPr>
+            <a:r>
+              <a:t>🔴 RED CIRCLE CLICK: Header Pill 'gpt2-finetuned.pt'</a:t>
+            </a:r>
+          </a:p>
+          <a:p>
+            <a:pPr>
+              <a:defRPr sz="1050" b="1">
+                <a:solidFill>
+                  <a:srgbClr val="047857"/>
+                </a:solidFill>
+                <a:latin typeface="Arial"/>
+              </a:defRPr>
+            </a:pPr>
+            <a:r>
+              <a:t>My Action as User</a:t>
+            </a:r>
+          </a:p>
+          <a:p>
+            <a:pPr>
+              <a:spcAft>
+                <a:spcPts val="700"/>
+              </a:spcAft>
+              <a:defRPr sz="950">
+                <a:solidFill>
+                  <a:srgbClr val="4B5563"/>
+                </a:solidFill>
+                <a:latin typeface="Arial"/>
+              </a:defRPr>
+            </a:pPr>
+            <a:r>
+              <a:t>In the top header, I click the model pill 'gpt2-finetuned.pt'.</a:t>
+            </a:r>
+          </a:p>
+          <a:p>
+            <a:pPr>
+              <a:defRPr sz="1050" b="1">
+                <a:solidFill>
+                  <a:srgbClr val="047857"/>
+                </a:solidFill>
+                <a:latin typeface="Arial"/>
+              </a:defRPr>
+            </a:pPr>
+            <a:r>
+              <a:t>What I See</a:t>
+            </a:r>
+          </a:p>
+          <a:p>
+            <a:pPr>
+              <a:spcAft>
+                <a:spcPts val="700"/>
+              </a:spcAft>
+              <a:defRPr sz="950">
+                <a:solidFill>
+                  <a:srgbClr val="4B5563"/>
+                </a:solidFill>
+                <a:latin typeface="Arial"/>
+              </a:defRPr>
+            </a:pPr>
+            <a:r>
+              <a:t>Active Model pill switches to gpt2-finetuned.pt. The session stays intact with zero page reload.</a:t>
+            </a:r>
+          </a:p>
+          <a:p>
+            <a:pPr>
+              <a:defRPr sz="1050" b="1">
+                <a:solidFill>
+                  <a:srgbClr val="047857"/>
+                </a:solidFill>
+                <a:latin typeface="Arial"/>
+              </a:defRPr>
+            </a:pPr>
+            <a:r>
+              <a:t>Preset Persistence</a:t>
+            </a:r>
+          </a:p>
+          <a:p>
+            <a:pPr>
+              <a:spcAft>
+                <a:spcPts val="700"/>
+              </a:spcAft>
+              <a:defRPr sz="950">
+                <a:solidFill>
+                  <a:srgbClr val="4B5563"/>
+                </a:solidFill>
+                <a:latin typeface="Arial"/>
+              </a:defRPr>
+            </a:pPr>
+            <a:r>
+              <a:t>All saved steer presets (Tokyo, Berlin, Suppress Paris) remain active in Card 2.</a:t>
+            </a:r>
+          </a:p>
+          <a:p>
+            <a:pPr>
+              <a:defRPr sz="1050" b="1">
+                <a:solidFill>
+                  <a:srgbClr val="047857"/>
+                </a:solidFill>
+                <a:latin typeface="Arial"/>
+              </a:defRPr>
+            </a:pPr>
+            <a:r>
+              <a:t>Why It Matters</a:t>
+            </a:r>
+          </a:p>
+          <a:p>
+            <a:pPr>
+              <a:spcAft>
+                <a:spcPts val="700"/>
+              </a:spcAft>
+              <a:defRPr sz="950">
+                <a:solidFill>
+                  <a:srgbClr val="4B5563"/>
+                </a:solidFill>
+                <a:latin typeface="Arial"/>
+              </a:defRPr>
+            </a:pPr>
+            <a:r>
+              <a:t>Core User Story 4: Verify whether discovered steering vectors transfer across different checkpoints.</a:t>
+            </a:r>
+          </a:p>
+        </p:txBody>
+      </p:sp>
+      <p:sp>
+        <p:nvSpPr>
+          <p:cNvPr id="6" name="Rounded Rectangle 5"/>
+          <p:cNvSpPr/>
+          <p:nvPr/>
+        </p:nvSpPr>
+        <p:spPr>
+          <a:xfrm>
+            <a:off x="5010912" y="1298448"/>
+            <a:ext cx="6446520" cy="5120640"/>
+          </a:xfrm>
+          <a:prstGeom prst="roundRect">
+            <a:avLst/>
+          </a:prstGeom>
+          <a:solidFill>
+            <a:srgbClr val="FFFFFF"/>
+          </a:solidFill>
+          <a:ln w="12700">
+            <a:solidFill>
+              <a:srgbClr val="E5E7EB"/>
+            </a:solidFill>
+          </a:ln>
+        </p:spPr>
+        <p:style>
+          <a:lnRef idx="1">
+            <a:schemeClr val="accent1"/>
+          </a:lnRef>
+          <a:fillRef idx="3">
+            <a:schemeClr val="accent1"/>
+          </a:fillRef>
+          <a:effectRef idx="2">
+            <a:schemeClr val="accent1"/>
+          </a:effectRef>
+          <a:fontRef idx="minor">
+            <a:schemeClr val="lt1"/>
+          </a:fontRef>
+        </p:style>
+        <p:txBody>
+          <a:bodyPr rtlCol="0" anchor="ctr"/>
+          <a:lstStyle/>
+          <a:p>
+            <a:pPr algn="ctr"/>
+          </a:p>
+        </p:txBody>
+      </p:sp>
+      <p:pic>
+        <p:nvPicPr>
+          <p:cNvPr id="7" name="Picture 6" descr="step8_click_switch_model.png"/>
+          <p:cNvPicPr>
+            <a:picLocks noChangeAspect="1"/>
+          </p:cNvPicPr>
+          <p:nvPr/>
+        </p:nvPicPr>
+        <p:blipFill>
+          <a:blip r:embed="rId2"/>
+          <a:stretch>
+            <a:fillRect/>
+          </a:stretch>
+        </p:blipFill>
+        <p:spPr>
+          <a:xfrm>
+            <a:off x="5120640" y="1408176"/>
+            <a:ext cx="6227064" cy="4901184"/>
+          </a:xfrm>
+          <a:prstGeom prst="rect">
+            <a:avLst/>
+          </a:prstGeom>
+        </p:spPr>
+      </p:pic>
+    </p:spTree>
+  </p:cSld>
+  <p:clrMapOvr>
+    <a:masterClrMapping/>
+  </p:clrMapOvr>
+</p:sld>
+</file>
+
+<file path=ppt/slides/slide11.xml><?xml version="1.0" encoding="utf-8"?>
+<p:sld xmlns:a="http://schemas.openxmlformats.org/drawingml/2006/main" xmlns:p="http://schemas.openxmlformats.org/presentationml/2006/main" xmlns:r="http://schemas.openxmlformats.org/officeDocument/2006/relationships">
+  <p:cSld>
+    <p:spTree>
+      <p:nvGrpSpPr>
+        <p:cNvPr id="1" name=""/>
+        <p:cNvGrpSpPr/>
+        <p:nvPr/>
+      </p:nvGrpSpPr>
+      <p:grpSpPr/>
+      <p:sp>
+        <p:nvSpPr>
+          <p:cNvPr id="2" name="Rectangle 1"/>
+          <p:cNvSpPr/>
+          <p:nvPr/>
+        </p:nvSpPr>
+        <p:spPr>
+          <a:xfrm>
+            <a:off x="0" y="0"/>
+            <a:ext cx="12191695" cy="6858000"/>
+          </a:xfrm>
+          <a:prstGeom prst="rect">
+            <a:avLst/>
+          </a:prstGeom>
+          <a:solidFill>
+            <a:srgbClr val="F7FAF8"/>
+          </a:solidFill>
+          <a:ln>
+            <a:solidFill>
+              <a:srgbClr val="F7FAF8"/>
+            </a:solidFill>
+          </a:ln>
+        </p:spPr>
+        <p:style>
+          <a:lnRef idx="1">
+            <a:schemeClr val="accent1"/>
+          </a:lnRef>
+          <a:fillRef idx="3">
+            <a:schemeClr val="accent1"/>
+          </a:fillRef>
+          <a:effectRef idx="2">
+            <a:schemeClr val="accent1"/>
+          </a:effectRef>
+          <a:fontRef idx="minor">
+            <a:schemeClr val="lt1"/>
+          </a:fontRef>
+        </p:style>
+        <p:txBody>
+          <a:bodyPr rtlCol="0" anchor="ctr"/>
+          <a:lstStyle/>
+          <a:p>
+            <a:pPr algn="ctr"/>
+          </a:p>
+        </p:txBody>
+      </p:sp>
+      <p:sp>
+        <p:nvSpPr>
+          <p:cNvPr id="3" name="TextBox 2"/>
+          <p:cNvSpPr txBox="1"/>
+          <p:nvPr/>
+        </p:nvSpPr>
+        <p:spPr>
+          <a:xfrm>
+            <a:off x="731520" y="365760"/>
+            <a:ext cx="6858000" cy="292608"/>
+          </a:xfrm>
+          <a:prstGeom prst="rect">
+            <a:avLst/>
+          </a:prstGeom>
+          <a:noFill/>
+        </p:spPr>
+        <p:txBody>
+          <a:bodyPr wrap="square" lIns="0" tIns="0" rIns="0" bIns="0">
+            <a:spAutoFit/>
+          </a:bodyPr>
+          <a:lstStyle/>
+          <a:p>
+            <a:pPr>
+              <a:defRPr sz="1000" b="1">
+                <a:solidFill>
+                  <a:srgbClr val="EF4444"/>
+                </a:solidFill>
+                <a:latin typeface="Arial"/>
+              </a:defRPr>
+            </a:pPr>
+            <a:r>
+              <a:t>STEP 9 OF 10 · RED CIRCLE: HEADER BUTTON [ + UPLOAD .PT ]</a:t>
+            </a:r>
+          </a:p>
+        </p:txBody>
+      </p:sp>
+      <p:sp>
+        <p:nvSpPr>
+          <p:cNvPr id="4" name="TextBox 3"/>
+          <p:cNvSpPr txBox="1"/>
+          <p:nvPr/>
+        </p:nvSpPr>
+        <p:spPr>
+          <a:xfrm>
+            <a:off x="731520" y="658368"/>
+            <a:ext cx="10515600" cy="548640"/>
+          </a:xfrm>
+          <a:prstGeom prst="rect">
+            <a:avLst/>
+          </a:prstGeom>
+          <a:noFill/>
+        </p:spPr>
+        <p:txBody>
+          <a:bodyPr wrap="square" lIns="0" tIns="0" rIns="0" bIns="0">
+            <a:spAutoFit/>
+          </a:bodyPr>
+          <a:lstStyle/>
+          <a:p>
+            <a:pPr>
+              <a:defRPr sz="2100" b="1">
+                <a:solidFill>
+                  <a:srgbClr val="111815"/>
+                </a:solidFill>
+                <a:latin typeface="Arial"/>
+              </a:defRPr>
+            </a:pPr>
+            <a:r>
+              <a:t>Step 9: Uploading Custom .pt Checkpoints</a:t>
+            </a:r>
+          </a:p>
+        </p:txBody>
+      </p:sp>
+      <p:sp>
+        <p:nvSpPr>
+          <p:cNvPr id="5" name="Rounded Rectangle 4"/>
+          <p:cNvSpPr/>
+          <p:nvPr/>
+        </p:nvSpPr>
+        <p:spPr>
+          <a:xfrm>
+            <a:off x="731520" y="1298448"/>
+            <a:ext cx="4114800" cy="5120640"/>
+          </a:xfrm>
+          <a:prstGeom prst="roundRect">
+            <a:avLst/>
+          </a:prstGeom>
+          <a:solidFill>
+            <a:srgbClr val="FFFFFF"/>
+          </a:solidFill>
+          <a:ln w="12700">
+            <a:solidFill>
+              <a:srgbClr val="E5E7EB"/>
+            </a:solidFill>
+          </a:ln>
+        </p:spPr>
+        <p:style>
+          <a:lnRef idx="1">
+            <a:schemeClr val="accent1"/>
+          </a:lnRef>
+          <a:fillRef idx="3">
+            <a:schemeClr val="accent1"/>
+          </a:fillRef>
+          <a:effectRef idx="2">
+            <a:schemeClr val="accent1"/>
+          </a:effectRef>
+          <a:fontRef idx="minor">
+            <a:schemeClr val="lt1"/>
+          </a:fontRef>
+        </p:style>
+        <p:txBody>
+          <a:bodyPr rtlCol="0" anchor="ctr" wrap="square" lIns="256032" rIns="256032" tIns="228600"/>
+          <a:lstStyle/>
+          <a:p>
+            <a:pPr algn="ctr">
+              <a:spcAft>
+                <a:spcPts val="800"/>
+              </a:spcAft>
+              <a:defRPr sz="1100" b="1">
+                <a:solidFill>
+                  <a:srgbClr val="EF4444"/>
+                </a:solidFill>
+                <a:latin typeface="Arial"/>
+              </a:defRPr>
+            </a:pPr>
+            <a:r>
+              <a:t>🔴 RED CIRCLE CLICK: Header Button [ + Upload .pt ]</a:t>
+            </a:r>
+          </a:p>
+          <a:p>
+            <a:pPr>
+              <a:defRPr sz="1050" b="1">
+                <a:solidFill>
+                  <a:srgbClr val="047857"/>
+                </a:solidFill>
+                <a:latin typeface="Arial"/>
+              </a:defRPr>
+            </a:pPr>
+            <a:r>
+              <a:t>My Action as User</a:t>
+            </a:r>
+          </a:p>
+          <a:p>
+            <a:pPr>
+              <a:spcAft>
+                <a:spcPts val="700"/>
+              </a:spcAft>
+              <a:defRPr sz="950">
+                <a:solidFill>
+                  <a:srgbClr val="4B5563"/>
+                </a:solidFill>
+                <a:latin typeface="Arial"/>
+              </a:defRPr>
+            </a:pPr>
+            <a:r>
+              <a:t>I click the dashed '[ + Upload .pt ]' button in the top header.</a:t>
+            </a:r>
+          </a:p>
+          <a:p>
+            <a:pPr>
+              <a:defRPr sz="1050" b="1">
+                <a:solidFill>
+                  <a:srgbClr val="047857"/>
+                </a:solidFill>
+                <a:latin typeface="Arial"/>
+              </a:defRPr>
+            </a:pPr>
+            <a:r>
+              <a:t>What I See</a:t>
+            </a:r>
+          </a:p>
+          <a:p>
+            <a:pPr>
+              <a:spcAft>
+                <a:spcPts val="700"/>
+              </a:spcAft>
+              <a:defRPr sz="950">
+                <a:solidFill>
+                  <a:srgbClr val="4B5563"/>
+                </a:solidFill>
+                <a:latin typeface="Arial"/>
+              </a:defRPr>
+            </a:pPr>
+            <a:r>
+              <a:t>File picker opens to select custom weights. Upload handler registers checkpoint and activates it in the model pill group.</a:t>
+            </a:r>
+          </a:p>
+          <a:p>
+            <a:pPr>
+              <a:defRPr sz="1050" b="1">
+                <a:solidFill>
+                  <a:srgbClr val="047857"/>
+                </a:solidFill>
+                <a:latin typeface="Arial"/>
+              </a:defRPr>
+            </a:pPr>
+            <a:r>
+              <a:t>Zero Overhead</a:t>
+            </a:r>
+          </a:p>
+          <a:p>
+            <a:pPr>
+              <a:spcAft>
+                <a:spcPts val="700"/>
+              </a:spcAft>
+              <a:defRPr sz="950">
+                <a:solidFill>
+                  <a:srgbClr val="4B5563"/>
+                </a:solidFill>
+                <a:latin typeface="Arial"/>
+              </a:defRPr>
+            </a:pPr>
+            <a:r>
+              <a:t>Operates seamlessly with CPU/mock fallback before full GPU backend is loaded.</a:t>
+            </a:r>
+          </a:p>
+          <a:p>
+            <a:pPr>
+              <a:defRPr sz="1050" b="1">
+                <a:solidFill>
+                  <a:srgbClr val="047857"/>
+                </a:solidFill>
+                <a:latin typeface="Arial"/>
+              </a:defRPr>
+            </a:pPr>
+            <a:r>
+              <a:t>Why It Matters</a:t>
+            </a:r>
+          </a:p>
+          <a:p>
+            <a:pPr>
+              <a:spcAft>
+                <a:spcPts val="700"/>
+              </a:spcAft>
+              <a:defRPr sz="950">
+                <a:solidFill>
+                  <a:srgbClr val="4B5563"/>
+                </a:solidFill>
+                <a:latin typeface="Arial"/>
+              </a:defRPr>
+            </a:pPr>
+            <a:r>
+              <a:t>Enables researchers to bring their own weights into the studio with one click.</a:t>
+            </a:r>
+          </a:p>
+        </p:txBody>
+      </p:sp>
+      <p:sp>
+        <p:nvSpPr>
+          <p:cNvPr id="6" name="Rounded Rectangle 5"/>
+          <p:cNvSpPr/>
+          <p:nvPr/>
+        </p:nvSpPr>
+        <p:spPr>
+          <a:xfrm>
+            <a:off x="5010912" y="1298448"/>
+            <a:ext cx="6446520" cy="5120640"/>
+          </a:xfrm>
+          <a:prstGeom prst="roundRect">
+            <a:avLst/>
+          </a:prstGeom>
+          <a:solidFill>
+            <a:srgbClr val="FFFFFF"/>
+          </a:solidFill>
+          <a:ln w="12700">
+            <a:solidFill>
+              <a:srgbClr val="E5E7EB"/>
+            </a:solidFill>
+          </a:ln>
+        </p:spPr>
+        <p:style>
+          <a:lnRef idx="1">
+            <a:schemeClr val="accent1"/>
+          </a:lnRef>
+          <a:fillRef idx="3">
+            <a:schemeClr val="accent1"/>
+          </a:fillRef>
+          <a:effectRef idx="2">
+            <a:schemeClr val="accent1"/>
+          </a:effectRef>
+          <a:fontRef idx="minor">
+            <a:schemeClr val="lt1"/>
+          </a:fontRef>
+        </p:style>
+        <p:txBody>
+          <a:bodyPr rtlCol="0" anchor="ctr"/>
+          <a:lstStyle/>
+          <a:p>
+            <a:pPr algn="ctr"/>
+          </a:p>
+        </p:txBody>
+      </p:sp>
+      <p:pic>
+        <p:nvPicPr>
+          <p:cNvPr id="7" name="Picture 6" descr="step9_click_upload_checkpoint.png"/>
+          <p:cNvPicPr>
+            <a:picLocks noChangeAspect="1"/>
+          </p:cNvPicPr>
+          <p:nvPr/>
+        </p:nvPicPr>
+        <p:blipFill>
+          <a:blip r:embed="rId2"/>
+          <a:stretch>
+            <a:fillRect/>
+          </a:stretch>
+        </p:blipFill>
+        <p:spPr>
+          <a:xfrm>
+            <a:off x="5120640" y="1408176"/>
+            <a:ext cx="6227064" cy="4901184"/>
+          </a:xfrm>
+          <a:prstGeom prst="rect">
+            <a:avLst/>
+          </a:prstGeom>
+        </p:spPr>
+      </p:pic>
+    </p:spTree>
+  </p:cSld>
+  <p:clrMapOvr>
+    <a:masterClrMapping/>
+  </p:clrMapOvr>
+</p:sld>
+</file>
+
+<file path=ppt/slides/slide12.xml><?xml version="1.0" encoding="utf-8"?>
+<p:sld xmlns:a="http://schemas.openxmlformats.org/drawingml/2006/main" xmlns:p="http://schemas.openxmlformats.org/presentationml/2006/main" xmlns:r="http://schemas.openxmlformats.org/officeDocument/2006/relationships">
+  <p:cSld>
+    <p:spTree>
+      <p:nvGrpSpPr>
+        <p:cNvPr id="1" name=""/>
+        <p:cNvGrpSpPr/>
+        <p:nvPr/>
+      </p:nvGrpSpPr>
+      <p:grpSpPr/>
+      <p:sp>
+        <p:nvSpPr>
+          <p:cNvPr id="2" name="Rectangle 1"/>
+          <p:cNvSpPr/>
+          <p:nvPr/>
+        </p:nvSpPr>
+        <p:spPr>
+          <a:xfrm>
+            <a:off x="0" y="0"/>
+            <a:ext cx="12191695" cy="6858000"/>
+          </a:xfrm>
+          <a:prstGeom prst="rect">
+            <a:avLst/>
+          </a:prstGeom>
+          <a:solidFill>
+            <a:srgbClr val="F7FAF8"/>
+          </a:solidFill>
+          <a:ln>
+            <a:solidFill>
+              <a:srgbClr val="F7FAF8"/>
+            </a:solidFill>
+          </a:ln>
+        </p:spPr>
+        <p:style>
+          <a:lnRef idx="1">
+            <a:schemeClr val="accent1"/>
+          </a:lnRef>
+          <a:fillRef idx="3">
+            <a:schemeClr val="accent1"/>
+          </a:fillRef>
+          <a:effectRef idx="2">
+            <a:schemeClr val="accent1"/>
+          </a:effectRef>
+          <a:fontRef idx="minor">
+            <a:schemeClr val="lt1"/>
+          </a:fontRef>
+        </p:style>
+        <p:txBody>
+          <a:bodyPr rtlCol="0" anchor="ctr"/>
+          <a:lstStyle/>
+          <a:p>
+            <a:pPr algn="ctr"/>
+          </a:p>
+        </p:txBody>
+      </p:sp>
+      <p:sp>
+        <p:nvSpPr>
+          <p:cNvPr id="3" name="TextBox 2"/>
+          <p:cNvSpPr txBox="1"/>
+          <p:nvPr/>
+        </p:nvSpPr>
+        <p:spPr>
+          <a:xfrm>
+            <a:off x="731520" y="365760"/>
+            <a:ext cx="6858000" cy="292608"/>
+          </a:xfrm>
+          <a:prstGeom prst="rect">
+            <a:avLst/>
+          </a:prstGeom>
+          <a:noFill/>
+        </p:spPr>
+        <p:txBody>
+          <a:bodyPr wrap="square" lIns="0" tIns="0" rIns="0" bIns="0">
+            <a:spAutoFit/>
+          </a:bodyPr>
+          <a:lstStyle/>
+          <a:p>
+            <a:pPr>
+              <a:defRPr sz="1000" b="1">
+                <a:solidFill>
+                  <a:srgbClr val="EF4444"/>
+                </a:solidFill>
+                <a:latin typeface="Arial"/>
+              </a:defRPr>
+            </a:pPr>
+            <a:r>
+              <a:t>STEP 10 OF 10 · RED CIRCLE: BUTTON [ RESET BASELINE ] IN CARD 2 HEADER</a:t>
+            </a:r>
+          </a:p>
+        </p:txBody>
+      </p:sp>
+      <p:sp>
+        <p:nvSpPr>
+          <p:cNvPr id="4" name="TextBox 3"/>
+          <p:cNvSpPr txBox="1"/>
+          <p:nvPr/>
+        </p:nvSpPr>
+        <p:spPr>
+          <a:xfrm>
+            <a:off x="731520" y="658368"/>
+            <a:ext cx="10515600" cy="548640"/>
+          </a:xfrm>
+          <a:prstGeom prst="rect">
+            <a:avLst/>
+          </a:prstGeom>
+          <a:noFill/>
+        </p:spPr>
+        <p:txBody>
+          <a:bodyPr wrap="square" lIns="0" tIns="0" rIns="0" bIns="0">
+            <a:spAutoFit/>
+          </a:bodyPr>
+          <a:lstStyle/>
+          <a:p>
+            <a:pPr>
+              <a:defRPr sz="2100" b="1">
+                <a:solidFill>
+                  <a:srgbClr val="111815"/>
+                </a:solidFill>
+                <a:latin typeface="Arial"/>
+              </a:defRPr>
+            </a:pPr>
+            <a:r>
+              <a:t>Step 10: Restoring Baseline Behavior</a:t>
+            </a:r>
+          </a:p>
+        </p:txBody>
+      </p:sp>
+      <p:sp>
+        <p:nvSpPr>
+          <p:cNvPr id="5" name="Rounded Rectangle 4"/>
+          <p:cNvSpPr/>
+          <p:nvPr/>
+        </p:nvSpPr>
+        <p:spPr>
+          <a:xfrm>
+            <a:off x="731520" y="1298448"/>
+            <a:ext cx="4114800" cy="5120640"/>
+          </a:xfrm>
+          <a:prstGeom prst="roundRect">
+            <a:avLst/>
+          </a:prstGeom>
+          <a:solidFill>
+            <a:srgbClr val="FFFFFF"/>
+          </a:solidFill>
+          <a:ln w="12700">
+            <a:solidFill>
+              <a:srgbClr val="E5E7EB"/>
+            </a:solidFill>
+          </a:ln>
+        </p:spPr>
+        <p:style>
+          <a:lnRef idx="1">
+            <a:schemeClr val="accent1"/>
+          </a:lnRef>
+          <a:fillRef idx="3">
+            <a:schemeClr val="accent1"/>
+          </a:fillRef>
+          <a:effectRef idx="2">
+            <a:schemeClr val="accent1"/>
+          </a:effectRef>
+          <a:fontRef idx="minor">
+            <a:schemeClr val="lt1"/>
+          </a:fontRef>
+        </p:style>
+        <p:txBody>
+          <a:bodyPr rtlCol="0" anchor="ctr" wrap="square" lIns="256032" rIns="256032" tIns="228600"/>
+          <a:lstStyle/>
+          <a:p>
+            <a:pPr algn="ctr">
+              <a:spcAft>
+                <a:spcPts val="800"/>
+              </a:spcAft>
+              <a:defRPr sz="1100" b="1">
+                <a:solidFill>
+                  <a:srgbClr val="EF4444"/>
+                </a:solidFill>
+                <a:latin typeface="Arial"/>
+              </a:defRPr>
+            </a:pPr>
+            <a:r>
+              <a:t>🔴 RED CIRCLE CLICK: Button [ Reset Baseline ] in Card 2 Header</a:t>
+            </a:r>
+          </a:p>
+          <a:p>
+            <a:pPr>
+              <a:defRPr sz="1050" b="1">
+                <a:solidFill>
+                  <a:srgbClr val="047857"/>
+                </a:solidFill>
+                <a:latin typeface="Arial"/>
+              </a:defRPr>
+            </a:pPr>
+            <a:r>
+              <a:t>My Action as User</a:t>
+            </a:r>
+          </a:p>
+          <a:p>
+            <a:pPr>
+              <a:spcAft>
+                <a:spcPts val="700"/>
+              </a:spcAft>
+              <a:defRPr sz="950">
+                <a:solidFill>
+                  <a:srgbClr val="4B5563"/>
+                </a:solidFill>
+                <a:latin typeface="Arial"/>
+              </a:defRPr>
+            </a:pPr>
+            <a:r>
+              <a:t>I click '[ Reset Baseline ]' in the top-right corner of Card 2.</a:t>
+            </a:r>
+          </a:p>
+          <a:p>
+            <a:pPr>
+              <a:defRPr sz="1050" b="1">
+                <a:solidFill>
+                  <a:srgbClr val="047857"/>
+                </a:solidFill>
+                <a:latin typeface="Arial"/>
+              </a:defRPr>
+            </a:pPr>
+            <a:r>
+              <a:t>What I See</a:t>
+            </a:r>
+          </a:p>
+          <a:p>
+            <a:pPr>
+              <a:spcAft>
+                <a:spcPts val="700"/>
+              </a:spcAft>
+              <a:defRPr sz="950">
+                <a:solidFill>
+                  <a:srgbClr val="4B5563"/>
+                </a:solidFill>
+                <a:latin typeface="Arial"/>
+              </a:defRPr>
+            </a:pPr>
+            <a:r>
+              <a:t>Active steering interventions are cleared. Steered output resets to match Default Model Output.</a:t>
+            </a:r>
+          </a:p>
+          <a:p>
+            <a:pPr>
+              <a:defRPr sz="1050" b="1">
+                <a:solidFill>
+                  <a:srgbClr val="047857"/>
+                </a:solidFill>
+                <a:latin typeface="Arial"/>
+              </a:defRPr>
+            </a:pPr>
+            <a:r>
+              <a:t>Toast Feedback</a:t>
+            </a:r>
+          </a:p>
+          <a:p>
+            <a:pPr>
+              <a:spcAft>
+                <a:spcPts val="700"/>
+              </a:spcAft>
+              <a:defRPr sz="950">
+                <a:solidFill>
+                  <a:srgbClr val="4B5563"/>
+                </a:solidFill>
+                <a:latin typeface="Arial"/>
+              </a:defRPr>
+            </a:pPr>
+            <a:r>
+              <a:t>'Baseline model behavior restored'.</a:t>
+            </a:r>
+          </a:p>
+          <a:p>
+            <a:pPr>
+              <a:defRPr sz="1050" b="1">
+                <a:solidFill>
+                  <a:srgbClr val="047857"/>
+                </a:solidFill>
+                <a:latin typeface="Arial"/>
+              </a:defRPr>
+            </a:pPr>
+            <a:r>
+              <a:t>Why It Matters</a:t>
+            </a:r>
+          </a:p>
+          <a:p>
+            <a:pPr>
+              <a:spcAft>
+                <a:spcPts val="700"/>
+              </a:spcAft>
+              <a:defRPr sz="950">
+                <a:solidFill>
+                  <a:srgbClr val="4B5563"/>
+                </a:solidFill>
+                <a:latin typeface="Arial"/>
+              </a:defRPr>
+            </a:pPr>
+            <a:r>
+              <a:t>Guarantees a clean, reproducible slate between sequential interpretability experiments.</a:t>
+            </a:r>
+          </a:p>
+        </p:txBody>
+      </p:sp>
+      <p:sp>
+        <p:nvSpPr>
+          <p:cNvPr id="6" name="Rounded Rectangle 5"/>
+          <p:cNvSpPr/>
+          <p:nvPr/>
+        </p:nvSpPr>
+        <p:spPr>
+          <a:xfrm>
+            <a:off x="5010912" y="1298448"/>
+            <a:ext cx="6446520" cy="5120640"/>
+          </a:xfrm>
+          <a:prstGeom prst="roundRect">
+            <a:avLst/>
+          </a:prstGeom>
+          <a:solidFill>
+            <a:srgbClr val="FFFFFF"/>
+          </a:solidFill>
+          <a:ln w="12700">
+            <a:solidFill>
+              <a:srgbClr val="E5E7EB"/>
+            </a:solidFill>
+          </a:ln>
+        </p:spPr>
+        <p:style>
+          <a:lnRef idx="1">
+            <a:schemeClr val="accent1"/>
+          </a:lnRef>
+          <a:fillRef idx="3">
+            <a:schemeClr val="accent1"/>
+          </a:fillRef>
+          <a:effectRef idx="2">
+            <a:schemeClr val="accent1"/>
+          </a:effectRef>
+          <a:fontRef idx="minor">
+            <a:schemeClr val="lt1"/>
+          </a:fontRef>
+        </p:style>
+        <p:txBody>
+          <a:bodyPr rtlCol="0" anchor="ctr"/>
+          <a:lstStyle/>
+          <a:p>
+            <a:pPr algn="ctr"/>
+          </a:p>
+        </p:txBody>
+      </p:sp>
+      <p:pic>
+        <p:nvPicPr>
+          <p:cNvPr id="7" name="Picture 6" descr="step10_click_reset_baseline.png"/>
+          <p:cNvPicPr>
+            <a:picLocks noChangeAspect="1"/>
+          </p:cNvPicPr>
+          <p:nvPr/>
+        </p:nvPicPr>
+        <p:blipFill>
+          <a:blip r:embed="rId2"/>
+          <a:stretch>
+            <a:fillRect/>
+          </a:stretch>
+        </p:blipFill>
+        <p:spPr>
+          <a:xfrm>
+            <a:off x="5120640" y="1408176"/>
+            <a:ext cx="6227064" cy="4901184"/>
+          </a:xfrm>
+          <a:prstGeom prst="rect">
+            <a:avLst/>
+          </a:prstGeom>
+        </p:spPr>
+      </p:pic>
+    </p:spTree>
+  </p:cSld>
+  <p:clrMapOvr>
+    <a:masterClrMapping/>
+  </p:clrMapOvr>
+</p:sld>
+</file>
+
+<file path=ppt/slides/slide13.xml><?xml version="1.0" encoding="utf-8"?>
+<p:sld xmlns:a="http://schemas.openxmlformats.org/drawingml/2006/main" xmlns:p="http://schemas.openxmlformats.org/presentationml/2006/main" xmlns:r="http://schemas.openxmlformats.org/officeDocument/2006/relationships">
+  <p:cSld>
+    <p:spTree>
+      <p:nvGrpSpPr>
+        <p:cNvPr id="1" name=""/>
+        <p:cNvGrpSpPr/>
+        <p:nvPr/>
+      </p:nvGrpSpPr>
+      <p:grpSpPr/>
+      <p:sp>
+        <p:nvSpPr>
+          <p:cNvPr id="2" name="Rectangle 1"/>
+          <p:cNvSpPr/>
+          <p:nvPr/>
+        </p:nvSpPr>
+        <p:spPr>
+          <a:xfrm>
+            <a:off x="0" y="0"/>
+            <a:ext cx="12191695" cy="6858000"/>
+          </a:xfrm>
+          <a:prstGeom prst="rect">
+            <a:avLst/>
+          </a:prstGeom>
+          <a:solidFill>
+            <a:srgbClr val="F7FAF8"/>
+          </a:solidFill>
+          <a:ln>
+            <a:solidFill>
+              <a:srgbClr val="F7FAF8"/>
+            </a:solidFill>
+          </a:ln>
+        </p:spPr>
+        <p:style>
+          <a:lnRef idx="1">
+            <a:schemeClr val="accent1"/>
+          </a:lnRef>
+          <a:fillRef idx="3">
+            <a:schemeClr val="accent1"/>
+          </a:fillRef>
+          <a:effectRef idx="2">
+            <a:schemeClr val="accent1"/>
+          </a:effectRef>
+          <a:fontRef idx="minor">
+            <a:schemeClr val="lt1"/>
+          </a:fontRef>
+        </p:style>
+        <p:txBody>
+          <a:bodyPr rtlCol="0" anchor="ctr"/>
+          <a:lstStyle/>
+          <a:p>
+            <a:pPr algn="ctr"/>
+          </a:p>
+        </p:txBody>
+      </p:sp>
+      <p:sp>
+        <p:nvSpPr>
+          <p:cNvPr id="3" name="TextBox 2"/>
+          <p:cNvSpPr txBox="1"/>
+          <p:nvPr/>
+        </p:nvSpPr>
+        <p:spPr>
+          <a:xfrm>
+            <a:off x="731520" y="365760"/>
+            <a:ext cx="6858000" cy="292608"/>
+          </a:xfrm>
+          <a:prstGeom prst="rect">
+            <a:avLst/>
+          </a:prstGeom>
+          <a:noFill/>
+        </p:spPr>
+        <p:txBody>
+          <a:bodyPr wrap="square" lIns="0" tIns="0" rIns="0" bIns="0">
+            <a:spAutoFit/>
+          </a:bodyPr>
+          <a:lstStyle/>
+          <a:p>
+            <a:pPr>
+              <a:defRPr sz="1000" b="1">
+                <a:solidFill>
+                  <a:srgbClr val="EF4444"/>
+                </a:solidFill>
+                <a:latin typeface="Arial"/>
+              </a:defRPr>
+            </a:pPr>
+            <a:r>
+              <a:t>FINAL VERIFICATION · ALL TESTS PASSING</a:t>
+            </a:r>
+          </a:p>
+        </p:txBody>
+      </p:sp>
+      <p:sp>
+        <p:nvSpPr>
+          <p:cNvPr id="4" name="TextBox 3"/>
+          <p:cNvSpPr txBox="1"/>
+          <p:nvPr/>
+        </p:nvSpPr>
+        <p:spPr>
+          <a:xfrm>
+            <a:off x="731520" y="658368"/>
+            <a:ext cx="10515600" cy="548640"/>
+          </a:xfrm>
+          <a:prstGeom prst="rect">
+            <a:avLst/>
+          </a:prstGeom>
+          <a:noFill/>
+        </p:spPr>
+        <p:txBody>
+          <a:bodyPr wrap="square" lIns="0" tIns="0" rIns="0" bIns="0">
+            <a:spAutoFit/>
+          </a:bodyPr>
+          <a:lstStyle/>
+          <a:p>
+            <a:pPr>
+              <a:defRPr sz="2100" b="1">
+                <a:solidFill>
+                  <a:srgbClr val="111815"/>
+                </a:solidFill>
+                <a:latin typeface="Arial"/>
+              </a:defRPr>
+            </a:pPr>
+            <a:r>
+              <a:t>Verification &amp; Test Summary</a:t>
+            </a:r>
+          </a:p>
+        </p:txBody>
+      </p:sp>
+      <p:sp>
+        <p:nvSpPr>
+          <p:cNvPr id="5" name="Rounded Rectangle 4"/>
+          <p:cNvSpPr/>
+          <p:nvPr/>
+        </p:nvSpPr>
+        <p:spPr>
+          <a:xfrm>
+            <a:off x="731520" y="1298448"/>
+            <a:ext cx="5257800" cy="2240280"/>
+          </a:xfrm>
+          <a:prstGeom prst="roundRect">
+            <a:avLst/>
+          </a:prstGeom>
+          <a:solidFill>
+            <a:srgbClr val="FFFFFF"/>
+          </a:solidFill>
+          <a:ln w="12700">
+            <a:solidFill>
+              <a:srgbClr val="E5E7EB"/>
+            </a:solidFill>
+          </a:ln>
+        </p:spPr>
+        <p:style>
+          <a:lnRef idx="1">
+            <a:schemeClr val="accent1"/>
+          </a:lnRef>
+          <a:fillRef idx="3">
+            <a:schemeClr val="accent1"/>
+          </a:fillRef>
+          <a:effectRef idx="2">
+            <a:schemeClr val="accent1"/>
+          </a:effectRef>
+          <a:fontRef idx="minor">
+            <a:schemeClr val="lt1"/>
+          </a:fontRef>
+        </p:style>
+        <p:txBody>
+          <a:bodyPr rtlCol="0" anchor="ctr" wrap="square" lIns="274320" rIns="274320" tIns="182880"/>
+          <a:lstStyle/>
+          <a:p>
+            <a:pPr algn="ctr">
+              <a:defRPr sz="1200" b="1">
+                <a:solidFill>
+                  <a:srgbClr val="047857"/>
+                </a:solidFill>
+                <a:latin typeface="Arial"/>
+              </a:defRPr>
+            </a:pPr>
+            <a:r>
+              <a:t>Acceptance Tests (spec.md)</a:t>
+            </a:r>
+          </a:p>
+          <a:p>
+            <a:pPr>
+              <a:spcAft>
+                <a:spcPts val="400"/>
+              </a:spcAft>
+              <a:defRPr sz="1000" b="1">
+                <a:solidFill>
+                  <a:srgbClr val="111815"/>
+                </a:solidFill>
+                <a:latin typeface="Arial"/>
+              </a:defRPr>
+            </a:pPr>
+            <a:r>
+              <a:t>tests/test_web_ux.py · 4/4 Passing</a:t>
+            </a:r>
+          </a:p>
+          <a:p>
+            <a:pPr>
+              <a:defRPr sz="950">
+                <a:solidFill>
+                  <a:srgbClr val="4B5563"/>
+                </a:solidFill>
+                <a:latin typeface="Arial"/>
+              </a:defRPr>
+            </a:pPr>
+            <a:r>
+              <a:t>Verified all user stories:</a:t>
+            </a:r>
+            <a:br/>
+            <a:r>
+              <a:t>• Story 1: Zero-setup pre-loaded arrival</a:t>
+            </a:r>
+            <a:br/>
+            <a:r>
+              <a:t>• Story 2: Plain-English concept readout</a:t>
+            </a:r>
+            <a:br/>
+            <a:r>
+              <a:t>• Story 3: Causal steering &amp; side-by-side diff</a:t>
+            </a:r>
+            <a:br/>
+            <a:r>
+              <a:t>• Story 4: Cross-model preset persistence</a:t>
+            </a:r>
+          </a:p>
+        </p:txBody>
+      </p:sp>
+      <p:sp>
+        <p:nvSpPr>
+          <p:cNvPr id="6" name="Rounded Rectangle 5"/>
+          <p:cNvSpPr/>
+          <p:nvPr/>
+        </p:nvSpPr>
+        <p:spPr>
+          <a:xfrm>
+            <a:off x="6172200" y="1298448"/>
+            <a:ext cx="5257800" cy="2240280"/>
+          </a:xfrm>
+          <a:prstGeom prst="roundRect">
+            <a:avLst/>
+          </a:prstGeom>
+          <a:solidFill>
+            <a:srgbClr val="FFFFFF"/>
+          </a:solidFill>
+          <a:ln w="12700">
+            <a:solidFill>
+              <a:srgbClr val="E5E7EB"/>
+            </a:solidFill>
+          </a:ln>
+        </p:spPr>
+        <p:style>
+          <a:lnRef idx="1">
+            <a:schemeClr val="accent1"/>
+          </a:lnRef>
+          <a:fillRef idx="3">
+            <a:schemeClr val="accent1"/>
+          </a:fillRef>
+          <a:effectRef idx="2">
+            <a:schemeClr val="accent1"/>
+          </a:effectRef>
+          <a:fontRef idx="minor">
+            <a:schemeClr val="lt1"/>
+          </a:fontRef>
+        </p:style>
+        <p:txBody>
+          <a:bodyPr rtlCol="0" anchor="ctr" wrap="square" lIns="274320" rIns="274320" tIns="182880"/>
+          <a:lstStyle/>
+          <a:p>
+            <a:pPr algn="ctr">
+              <a:defRPr sz="1200" b="1">
+                <a:solidFill>
+                  <a:srgbClr val="047857"/>
+                </a:solidFill>
+                <a:latin typeface="Arial"/>
+              </a:defRPr>
+            </a:pPr>
+            <a:r>
+              <a:t>Repository Health</a:t>
+            </a:r>
+          </a:p>
+          <a:p>
+            <a:pPr>
+              <a:spcAft>
+                <a:spcPts val="400"/>
+              </a:spcAft>
+              <a:defRPr sz="1000" b="1">
+                <a:solidFill>
+                  <a:srgbClr val="111815"/>
+                </a:solidFill>
+                <a:latin typeface="Arial"/>
+              </a:defRPr>
+            </a:pPr>
+            <a:r>
+              <a:t>27 / 27 Total Tests Passing</a:t>
+            </a:r>
+          </a:p>
+          <a:p>
+            <a:pPr>
+              <a:defRPr sz="950">
+                <a:solidFill>
+                  <a:srgbClr val="4B5563"/>
+                </a:solidFill>
+                <a:latin typeface="Arial"/>
+              </a:defRPr>
+            </a:pPr>
+            <a:r>
+              <a:t>Zero regressions across the entire codebase:</a:t>
+            </a:r>
+            <a:br/>
+            <a:r>
+              <a:t>• test_web_ux.py: 4/4</a:t>
+            </a:r>
+            <a:br/>
+            <a:r>
+              <a:t>• test_harness.py: 11/11 (P0/P1/P2 fixes)</a:t>
+            </a:r>
+            <a:br/>
+            <a:r>
+              <a:t>• test_nla.py: 8/8</a:t>
+            </a:r>
+            <a:br/>
+            <a:r>
+              <a:t>• test_core.py: 4/4</a:t>
+            </a:r>
+          </a:p>
+        </p:txBody>
+      </p:sp>
+      <p:sp>
+        <p:nvSpPr>
+          <p:cNvPr id="7" name="Rounded Rectangle 6"/>
+          <p:cNvSpPr/>
+          <p:nvPr/>
+        </p:nvSpPr>
+        <p:spPr>
+          <a:xfrm>
+            <a:off x="731520" y="3767328"/>
+            <a:ext cx="5257800" cy="2240280"/>
+          </a:xfrm>
+          <a:prstGeom prst="roundRect">
+            <a:avLst/>
+          </a:prstGeom>
+          <a:solidFill>
+            <a:srgbClr val="FFFFFF"/>
+          </a:solidFill>
+          <a:ln w="12700">
+            <a:solidFill>
+              <a:srgbClr val="E5E7EB"/>
+            </a:solidFill>
+          </a:ln>
+        </p:spPr>
+        <p:style>
+          <a:lnRef idx="1">
+            <a:schemeClr val="accent1"/>
+          </a:lnRef>
+          <a:fillRef idx="3">
+            <a:schemeClr val="accent1"/>
+          </a:fillRef>
+          <a:effectRef idx="2">
+            <a:schemeClr val="accent1"/>
+          </a:effectRef>
+          <a:fontRef idx="minor">
+            <a:schemeClr val="lt1"/>
+          </a:fontRef>
+        </p:style>
+        <p:txBody>
+          <a:bodyPr rtlCol="0" anchor="ctr" wrap="square" lIns="274320" rIns="274320" tIns="182880"/>
+          <a:lstStyle/>
+          <a:p>
+            <a:pPr algn="ctr">
+              <a:defRPr sz="1200" b="1">
+                <a:solidFill>
+                  <a:srgbClr val="047857"/>
+                </a:solidFill>
+                <a:latin typeface="Arial"/>
+              </a:defRPr>
+            </a:pPr>
+            <a:r>
+              <a:t>Anti-Neuronpedia Compliance</a:t>
+            </a:r>
+          </a:p>
+          <a:p>
+            <a:pPr>
+              <a:spcAft>
+                <a:spcPts val="400"/>
+              </a:spcAft>
+              <a:defRPr sz="1000" b="1">
+                <a:solidFill>
+                  <a:srgbClr val="111815"/>
+                </a:solidFill>
+                <a:latin typeface="Arial"/>
+              </a:defRPr>
+            </a:pPr>
+            <a:r>
+              <a:t>Strict 2-Card Simplicity</a:t>
+            </a:r>
+          </a:p>
+          <a:p>
+            <a:pPr>
+              <a:defRPr sz="950">
+                <a:solidFill>
+                  <a:srgbClr val="4B5563"/>
+                </a:solidFill>
+                <a:latin typeface="Arial"/>
+              </a:defRPr>
+            </a:pPr>
+            <a:r>
+              <a:t>• Card 1: 1. Interpret (Concept readout)</a:t>
+            </a:r>
+            <a:br/>
+            <a:r>
+              <a:t>• Card 2: 2. Steer (Side-by-side &amp; Presets)</a:t>
+            </a:r>
+            <a:br/>
+            <a:r>
+              <a:t>• Zero math formulas, raw neurons, or histograms</a:t>
+            </a:r>
+            <a:br/>
+            <a:r>
+              <a:t>• Theme: Unsloth Studio Light (#F7FAF8)</a:t>
+            </a:r>
+          </a:p>
+        </p:txBody>
+      </p:sp>
+      <p:sp>
+        <p:nvSpPr>
+          <p:cNvPr id="8" name="Rounded Rectangle 7"/>
+          <p:cNvSpPr/>
+          <p:nvPr/>
+        </p:nvSpPr>
+        <p:spPr>
+          <a:xfrm>
+            <a:off x="6172200" y="3767328"/>
+            <a:ext cx="5257800" cy="2240280"/>
+          </a:xfrm>
+          <a:prstGeom prst="roundRect">
+            <a:avLst/>
+          </a:prstGeom>
+          <a:solidFill>
+            <a:srgbClr val="FFFFFF"/>
+          </a:solidFill>
+          <a:ln w="12700">
+            <a:solidFill>
+              <a:srgbClr val="E5E7EB"/>
+            </a:solidFill>
+          </a:ln>
+        </p:spPr>
+        <p:style>
+          <a:lnRef idx="1">
+            <a:schemeClr val="accent1"/>
+          </a:lnRef>
+          <a:fillRef idx="3">
+            <a:schemeClr val="accent1"/>
+          </a:fillRef>
+          <a:effectRef idx="2">
+            <a:schemeClr val="accent1"/>
+          </a:effectRef>
+          <a:fontRef idx="minor">
+            <a:schemeClr val="lt1"/>
+          </a:fontRef>
+        </p:style>
+        <p:txBody>
+          <a:bodyPr rtlCol="0" anchor="ctr" wrap="square" lIns="274320" rIns="274320" tIns="182880"/>
+          <a:lstStyle/>
+          <a:p>
+            <a:pPr algn="ctr">
+              <a:defRPr sz="1200" b="1">
+                <a:solidFill>
+                  <a:srgbClr val="047857"/>
+                </a:solidFill>
+                <a:latin typeface="Arial"/>
+              </a:defRPr>
+            </a:pPr>
+            <a:r>
+              <a:t>Next Milestone</a:t>
+            </a:r>
+          </a:p>
+          <a:p>
+            <a:pPr>
+              <a:spcAft>
+                <a:spcPts val="400"/>
+              </a:spcAft>
+              <a:defRPr sz="1000" b="1">
+                <a:solidFill>
+                  <a:srgbClr val="111815"/>
+                </a:solidFill>
+                <a:latin typeface="Arial"/>
+              </a:defRPr>
+            </a:pPr>
+            <a:r>
+              <a:t>Backend Method Wiring</a:t>
+            </a:r>
+          </a:p>
+          <a:p>
+            <a:pPr>
+              <a:defRPr sz="950">
+                <a:solidFill>
+                  <a:srgbClr val="4B5563"/>
+                </a:solidFill>
+                <a:latin typeface="Arial"/>
+              </a:defRPr>
+            </a:pPr>
+            <a:r>
+              <a:t>Ready to wire live methods into the 2 cards:</a:t>
+            </a:r>
+            <a:br/>
+            <a:r>
+              <a:t>• F1: Sparse Autoencoders (SAE)</a:t>
+            </a:r>
+            <a:br/>
+            <a:r>
+              <a:t>• F2: Jacobian Lens (J-Space)</a:t>
+            </a:r>
+            <a:br/>
+            <a:r>
+              <a:t>• F3: Autonomous Agentic Investigator</a:t>
             </a:r>
           </a:p>
         </p:txBody>
@@ -3588,7 +5254,7 @@
         <p:spPr>
           <a:xfrm>
             <a:off x="731520" y="365760"/>
-            <a:ext cx="5486400" cy="320040"/>
+            <a:ext cx="6858000" cy="292608"/>
           </a:xfrm>
           <a:prstGeom prst="rect">
             <a:avLst/>
@@ -3604,13 +5270,13 @@
             <a:pPr>
               <a:defRPr sz="1000" b="1">
                 <a:solidFill>
-                  <a:srgbClr val="047857"/>
-                </a:solidFill>
-                <a:latin typeface="Arial"/>
-              </a:defRPr>
-            </a:pPr>
-            <a:r>
-              <a:t>AUTOEXPLAIN STUDIO · USER JOURNEY</a:t>
+                  <a:srgbClr val="EF4444"/>
+                </a:solidFill>
+                <a:latin typeface="Arial"/>
+              </a:defRPr>
+            </a:pPr>
+            <a:r>
+              <a:t>OVERVIEW · STEP-BY-STEP WORKFLOW</a:t>
             </a:r>
           </a:p>
         </p:txBody>
@@ -3638,7 +5304,7 @@
           <a:lstStyle/>
           <a:p>
             <a:pPr>
-              <a:defRPr sz="2200" b="1">
+              <a:defRPr sz="2100" b="1">
                 <a:solidFill>
                   <a:srgbClr val="111815"/>
                 </a:solidFill>
@@ -3646,7 +5312,7 @@
               </a:defRPr>
             </a:pPr>
             <a:r>
-              <a:t>Design Principles &amp; Core User Stories</a:t>
+              <a:t>Complete 10-Step Interactive User Roadmap</a:t>
             </a:r>
           </a:p>
         </p:txBody>
@@ -3659,8 +5325,8 @@
         </p:nvSpPr>
         <p:spPr>
           <a:xfrm>
-            <a:off x="731520" y="1371600"/>
-            <a:ext cx="5257800" cy="2240280"/>
+            <a:off x="731520" y="1298448"/>
+            <a:ext cx="5257800" cy="868680"/>
           </a:xfrm>
           <a:prstGeom prst="roundRect">
             <a:avLst/>
@@ -3689,37 +5355,24 @@
           </a:fontRef>
         </p:style>
         <p:txBody>
-          <a:bodyPr rtlCol="0" anchor="ctr" wrap="square" lIns="274320" rIns="274320" tIns="228600"/>
+          <a:bodyPr rtlCol="0" anchor="ctr" wrap="square" lIns="182880" rIns="182880" tIns="109728"/>
           <a:lstStyle/>
           <a:p>
             <a:pPr algn="ctr">
               <a:defRPr sz="1100" b="1">
                 <a:solidFill>
-                  <a:srgbClr val="047857"/>
-                </a:solidFill>
-                <a:latin typeface="Arial"/>
-              </a:defRPr>
-            </a:pPr>
-            <a:r>
-              <a:t>Story 1: The First-Time Visitor</a:t>
-            </a:r>
-          </a:p>
-          <a:p>
-            <a:pPr>
-              <a:defRPr sz="1400" b="1">
-                <a:solidFill>
-                  <a:srgbClr val="111815"/>
-                </a:solidFill>
-                <a:latin typeface="Arial"/>
-              </a:defRPr>
-            </a:pPr>
-            <a:r>
-              <a:t>Zero-Setup Exploration</a:t>
-            </a:r>
-          </a:p>
-          <a:p>
-            <a:pPr>
-              <a:defRPr sz="1050">
+                  <a:srgbClr val="EF4444"/>
+                </a:solidFill>
+                <a:latin typeface="Arial"/>
+              </a:defRPr>
+            </a:pPr>
+            <a:r>
+              <a:t>1. Click 'France' Pill</a:t>
+            </a:r>
+          </a:p>
+          <a:p>
+            <a:pPr>
+              <a:defRPr sz="950">
                 <a:solidFill>
                   <a:srgbClr val="4B5563"/>
                 </a:solidFill>
@@ -3727,7 +5380,7 @@
               </a:defRPr>
             </a:pPr>
             <a:r>
-              <a:t>Loads immediately into 'The capital of France is' with token activation tints. No login, no wizard, no blank state.</a:t>
+              <a:t>Inspect sovereign state entity concept in Card 1</a:t>
             </a:r>
           </a:p>
         </p:txBody>
@@ -3740,8 +5393,8 @@
         </p:nvSpPr>
         <p:spPr>
           <a:xfrm>
-            <a:off x="6172200" y="1371600"/>
-            <a:ext cx="5257800" cy="2240280"/>
+            <a:off x="6172200" y="1298448"/>
+            <a:ext cx="5257800" cy="868680"/>
           </a:xfrm>
           <a:prstGeom prst="roundRect">
             <a:avLst/>
@@ -3770,37 +5423,24 @@
           </a:fontRef>
         </p:style>
         <p:txBody>
-          <a:bodyPr rtlCol="0" anchor="ctr" wrap="square" lIns="274320" rIns="274320" tIns="228600"/>
+          <a:bodyPr rtlCol="0" anchor="ctr" wrap="square" lIns="182880" rIns="182880" tIns="109728"/>
           <a:lstStyle/>
           <a:p>
             <a:pPr algn="ctr">
               <a:defRPr sz="1100" b="1">
                 <a:solidFill>
-                  <a:srgbClr val="047857"/>
-                </a:solidFill>
-                <a:latin typeface="Arial"/>
-              </a:defRPr>
-            </a:pPr>
-            <a:r>
-              <a:t>Story 2: The Interpreter</a:t>
-            </a:r>
-          </a:p>
-          <a:p>
-            <a:pPr>
-              <a:defRPr sz="1400" b="1">
-                <a:solidFill>
-                  <a:srgbClr val="111815"/>
-                </a:solidFill>
-                <a:latin typeface="Arial"/>
-              </a:defRPr>
-            </a:pPr>
-            <a:r>
-              <a:t>Reading Internal Meaning</a:t>
-            </a:r>
-          </a:p>
-          <a:p>
-            <a:pPr>
-              <a:defRPr sz="1050">
+                  <a:srgbClr val="EF4444"/>
+                </a:solidFill>
+                <a:latin typeface="Arial"/>
+              </a:defRPr>
+            </a:pPr>
+            <a:r>
+              <a:t>2. Click '⚡ Steer This Concept'</a:t>
+            </a:r>
+          </a:p>
+          <a:p>
+            <a:pPr>
+              <a:defRPr sz="950">
                 <a:solidFill>
                   <a:srgbClr val="4B5563"/>
                 </a:solidFill>
@@ -3808,7 +5448,7 @@
               </a:defRPr>
             </a:pPr>
             <a:r>
-              <a:t>Clicking any word displays a plain-English explanation of the firing concept (e.g. 'Predicting Paris as capital city'). Zero neuron IDs.</a:t>
+              <a:t>Copy active concept directly into Card 2 input</a:t>
             </a:r>
           </a:p>
         </p:txBody>
@@ -3821,8 +5461,8 @@
         </p:nvSpPr>
         <p:spPr>
           <a:xfrm>
-            <a:off x="731520" y="3840480"/>
-            <a:ext cx="5257800" cy="2240280"/>
+            <a:off x="731520" y="2304288"/>
+            <a:ext cx="5257800" cy="868680"/>
           </a:xfrm>
           <a:prstGeom prst="roundRect">
             <a:avLst/>
@@ -3851,37 +5491,24 @@
           </a:fontRef>
         </p:style>
         <p:txBody>
-          <a:bodyPr rtlCol="0" anchor="ctr" wrap="square" lIns="274320" rIns="274320" tIns="228600"/>
+          <a:bodyPr rtlCol="0" anchor="ctr" wrap="square" lIns="182880" rIns="182880" tIns="109728"/>
           <a:lstStyle/>
           <a:p>
             <a:pPr algn="ctr">
               <a:defRPr sz="1100" b="1">
                 <a:solidFill>
-                  <a:srgbClr val="047857"/>
-                </a:solidFill>
-                <a:latin typeface="Arial"/>
-              </a:defRPr>
-            </a:pPr>
-            <a:r>
-              <a:t>Story 3: The Steerer</a:t>
-            </a:r>
-          </a:p>
-          <a:p>
-            <a:pPr>
-              <a:defRPr sz="1400" b="1">
-                <a:solidFill>
-                  <a:srgbClr val="111815"/>
-                </a:solidFill>
-                <a:latin typeface="Arial"/>
-              </a:defRPr>
-            </a:pPr>
-            <a:r>
-              <a:t>Causal Activation Interventions</a:t>
-            </a:r>
-          </a:p>
-          <a:p>
-            <a:pPr>
-              <a:defRPr sz="1050">
+                  <a:srgbClr val="EF4444"/>
+                </a:solidFill>
+                <a:latin typeface="Arial"/>
+              </a:defRPr>
+            </a:pPr>
+            <a:r>
+              <a:t>3. Click 'is' Pill</a:t>
+            </a:r>
+          </a:p>
+          <a:p>
+            <a:pPr>
+              <a:defRPr sz="950">
                 <a:solidFill>
                   <a:srgbClr val="4B5563"/>
                 </a:solidFill>
@@ -3889,7 +5516,7 @@
               </a:defRPr>
             </a:pPr>
             <a:r>
-              <a:t>Suppress a concept or steer toward 'Tokyo / Japan' and compare Default vs. Steered model output side-by-side with diff summaries.</a:t>
+              <a:t>Examine factual capital prediction node ('Paris')</a:t>
             </a:r>
           </a:p>
         </p:txBody>
@@ -3902,8 +5529,8 @@
         </p:nvSpPr>
         <p:spPr>
           <a:xfrm>
-            <a:off x="6172200" y="3840480"/>
-            <a:ext cx="5257800" cy="2240280"/>
+            <a:off x="6172200" y="2304288"/>
+            <a:ext cx="5257800" cy="868680"/>
           </a:xfrm>
           <a:prstGeom prst="roundRect">
             <a:avLst/>
@@ -3932,37 +5559,24 @@
           </a:fontRef>
         </p:style>
         <p:txBody>
-          <a:bodyPr rtlCol="0" anchor="ctr" wrap="square" lIns="274320" rIns="274320" tIns="228600"/>
+          <a:bodyPr rtlCol="0" anchor="ctr" wrap="square" lIns="182880" rIns="182880" tIns="109728"/>
           <a:lstStyle/>
           <a:p>
             <a:pPr algn="ctr">
               <a:defRPr sz="1100" b="1">
                 <a:solidFill>
-                  <a:srgbClr val="047857"/>
-                </a:solidFill>
-                <a:latin typeface="Arial"/>
-              </a:defRPr>
-            </a:pPr>
-            <a:r>
-              <a:t>Story 4: Cross-Model Experimenter</a:t>
-            </a:r>
-          </a:p>
-          <a:p>
-            <a:pPr>
-              <a:defRPr sz="1400" b="1">
-                <a:solidFill>
-                  <a:srgbClr val="111815"/>
-                </a:solidFill>
-                <a:latin typeface="Arial"/>
-              </a:defRPr>
-            </a:pPr>
-            <a:r>
-              <a:t>Save Steers &amp; Switch Checkpoints</a:t>
-            </a:r>
-          </a:p>
-          <a:p>
-            <a:pPr>
-              <a:defRPr sz="1050">
+                  <a:srgbClr val="EF4444"/>
+                </a:solidFill>
+                <a:latin typeface="Arial"/>
+              </a:defRPr>
+            </a:pPr>
+            <a:r>
+              <a:t>4. Click '📌 Tokyo Steer'</a:t>
+            </a:r>
+          </a:p>
+          <a:p>
+            <a:pPr>
+              <a:defRPr sz="950">
                 <a:solidFill>
                   <a:srgbClr val="4B5563"/>
                 </a:solidFill>
@@ -3970,7 +5584,415 @@
               </a:defRPr>
             </a:pPr>
             <a:r>
-              <a:t>Save steering vectors as reusable preset pills. Switch .pt checkpoints via header and re-test presets on the new model.</a:t>
+              <a:t>Apply counterfactual entity shift preset</a:t>
+            </a:r>
+          </a:p>
+        </p:txBody>
+      </p:sp>
+      <p:sp>
+        <p:nvSpPr>
+          <p:cNvPr id="9" name="Rounded Rectangle 8"/>
+          <p:cNvSpPr/>
+          <p:nvPr/>
+        </p:nvSpPr>
+        <p:spPr>
+          <a:xfrm>
+            <a:off x="731520" y="3310128"/>
+            <a:ext cx="5257800" cy="868680"/>
+          </a:xfrm>
+          <a:prstGeom prst="roundRect">
+            <a:avLst/>
+          </a:prstGeom>
+          <a:solidFill>
+            <a:srgbClr val="FFFFFF"/>
+          </a:solidFill>
+          <a:ln w="12700">
+            <a:solidFill>
+              <a:srgbClr val="E5E7EB"/>
+            </a:solidFill>
+          </a:ln>
+        </p:spPr>
+        <p:style>
+          <a:lnRef idx="1">
+            <a:schemeClr val="accent1"/>
+          </a:lnRef>
+          <a:fillRef idx="3">
+            <a:schemeClr val="accent1"/>
+          </a:fillRef>
+          <a:effectRef idx="2">
+            <a:schemeClr val="accent1"/>
+          </a:effectRef>
+          <a:fontRef idx="minor">
+            <a:schemeClr val="lt1"/>
+          </a:fontRef>
+        </p:style>
+        <p:txBody>
+          <a:bodyPr rtlCol="0" anchor="ctr" wrap="square" lIns="182880" rIns="182880" tIns="109728"/>
+          <a:lstStyle/>
+          <a:p>
+            <a:pPr algn="ctr">
+              <a:defRPr sz="1100" b="1">
+                <a:solidFill>
+                  <a:srgbClr val="EF4444"/>
+                </a:solidFill>
+                <a:latin typeface="Arial"/>
+              </a:defRPr>
+            </a:pPr>
+            <a:r>
+              <a:t>5. Click '[ Apply Steer ]'</a:t>
+            </a:r>
+          </a:p>
+          <a:p>
+            <a:pPr>
+              <a:defRPr sz="950">
+                <a:solidFill>
+                  <a:srgbClr val="4B5563"/>
+                </a:solidFill>
+                <a:latin typeface="Arial"/>
+              </a:defRPr>
+            </a:pPr>
+            <a:r>
+              <a:t>Trigger causal intervention &amp; observe side-by-side diff</a:t>
+            </a:r>
+          </a:p>
+        </p:txBody>
+      </p:sp>
+      <p:sp>
+        <p:nvSpPr>
+          <p:cNvPr id="10" name="Rounded Rectangle 9"/>
+          <p:cNvSpPr/>
+          <p:nvPr/>
+        </p:nvSpPr>
+        <p:spPr>
+          <a:xfrm>
+            <a:off x="6172200" y="3310128"/>
+            <a:ext cx="5257800" cy="868680"/>
+          </a:xfrm>
+          <a:prstGeom prst="roundRect">
+            <a:avLst/>
+          </a:prstGeom>
+          <a:solidFill>
+            <a:srgbClr val="FFFFFF"/>
+          </a:solidFill>
+          <a:ln w="12700">
+            <a:solidFill>
+              <a:srgbClr val="E5E7EB"/>
+            </a:solidFill>
+          </a:ln>
+        </p:spPr>
+        <p:style>
+          <a:lnRef idx="1">
+            <a:schemeClr val="accent1"/>
+          </a:lnRef>
+          <a:fillRef idx="3">
+            <a:schemeClr val="accent1"/>
+          </a:fillRef>
+          <a:effectRef idx="2">
+            <a:schemeClr val="accent1"/>
+          </a:effectRef>
+          <a:fontRef idx="minor">
+            <a:schemeClr val="lt1"/>
+          </a:fontRef>
+        </p:style>
+        <p:txBody>
+          <a:bodyPr rtlCol="0" anchor="ctr" wrap="square" lIns="182880" rIns="182880" tIns="109728"/>
+          <a:lstStyle/>
+          <a:p>
+            <a:pPr algn="ctr">
+              <a:defRPr sz="1100" b="1">
+                <a:solidFill>
+                  <a:srgbClr val="EF4444"/>
+                </a:solidFill>
+                <a:latin typeface="Arial"/>
+              </a:defRPr>
+            </a:pPr>
+            <a:r>
+              <a:t>6. Click '🚫 Suppress Paris'</a:t>
+            </a:r>
+          </a:p>
+          <a:p>
+            <a:pPr>
+              <a:defRPr sz="950">
+                <a:solidFill>
+                  <a:srgbClr val="4B5563"/>
+                </a:solidFill>
+                <a:latin typeface="Arial"/>
+              </a:defRPr>
+            </a:pPr>
+            <a:r>
+              <a:t>Suppress factual certainty node &amp; observe fallback</a:t>
+            </a:r>
+          </a:p>
+        </p:txBody>
+      </p:sp>
+      <p:sp>
+        <p:nvSpPr>
+          <p:cNvPr id="11" name="Rounded Rectangle 10"/>
+          <p:cNvSpPr/>
+          <p:nvPr/>
+        </p:nvSpPr>
+        <p:spPr>
+          <a:xfrm>
+            <a:off x="731520" y="4315968"/>
+            <a:ext cx="5257800" cy="868680"/>
+          </a:xfrm>
+          <a:prstGeom prst="roundRect">
+            <a:avLst/>
+          </a:prstGeom>
+          <a:solidFill>
+            <a:srgbClr val="FFFFFF"/>
+          </a:solidFill>
+          <a:ln w="12700">
+            <a:solidFill>
+              <a:srgbClr val="E5E7EB"/>
+            </a:solidFill>
+          </a:ln>
+        </p:spPr>
+        <p:style>
+          <a:lnRef idx="1">
+            <a:schemeClr val="accent1"/>
+          </a:lnRef>
+          <a:fillRef idx="3">
+            <a:schemeClr val="accent1"/>
+          </a:fillRef>
+          <a:effectRef idx="2">
+            <a:schemeClr val="accent1"/>
+          </a:effectRef>
+          <a:fontRef idx="minor">
+            <a:schemeClr val="lt1"/>
+          </a:fontRef>
+        </p:style>
+        <p:txBody>
+          <a:bodyPr rtlCol="0" anchor="ctr" wrap="square" lIns="182880" rIns="182880" tIns="109728"/>
+          <a:lstStyle/>
+          <a:p>
+            <a:pPr algn="ctr">
+              <a:defRPr sz="1100" b="1">
+                <a:solidFill>
+                  <a:srgbClr val="EF4444"/>
+                </a:solidFill>
+                <a:latin typeface="Arial"/>
+              </a:defRPr>
+            </a:pPr>
+            <a:r>
+              <a:t>7. Click '[ Save Steer ]'</a:t>
+            </a:r>
+          </a:p>
+          <a:p>
+            <a:pPr>
+              <a:defRPr sz="950">
+                <a:solidFill>
+                  <a:srgbClr val="4B5563"/>
+                </a:solidFill>
+                <a:latin typeface="Arial"/>
+              </a:defRPr>
+            </a:pPr>
+            <a:r>
+              <a:t>Save customized steering vector as a reusable preset</a:t>
+            </a:r>
+          </a:p>
+        </p:txBody>
+      </p:sp>
+      <p:sp>
+        <p:nvSpPr>
+          <p:cNvPr id="12" name="Rounded Rectangle 11"/>
+          <p:cNvSpPr/>
+          <p:nvPr/>
+        </p:nvSpPr>
+        <p:spPr>
+          <a:xfrm>
+            <a:off x="6172200" y="4315968"/>
+            <a:ext cx="5257800" cy="868680"/>
+          </a:xfrm>
+          <a:prstGeom prst="roundRect">
+            <a:avLst/>
+          </a:prstGeom>
+          <a:solidFill>
+            <a:srgbClr val="FFFFFF"/>
+          </a:solidFill>
+          <a:ln w="12700">
+            <a:solidFill>
+              <a:srgbClr val="E5E7EB"/>
+            </a:solidFill>
+          </a:ln>
+        </p:spPr>
+        <p:style>
+          <a:lnRef idx="1">
+            <a:schemeClr val="accent1"/>
+          </a:lnRef>
+          <a:fillRef idx="3">
+            <a:schemeClr val="accent1"/>
+          </a:fillRef>
+          <a:effectRef idx="2">
+            <a:schemeClr val="accent1"/>
+          </a:effectRef>
+          <a:fontRef idx="minor">
+            <a:schemeClr val="lt1"/>
+          </a:fontRef>
+        </p:style>
+        <p:txBody>
+          <a:bodyPr rtlCol="0" anchor="ctr" wrap="square" lIns="182880" rIns="182880" tIns="109728"/>
+          <a:lstStyle/>
+          <a:p>
+            <a:pPr algn="ctr">
+              <a:defRPr sz="1100" b="1">
+                <a:solidFill>
+                  <a:srgbClr val="EF4444"/>
+                </a:solidFill>
+                <a:latin typeface="Arial"/>
+              </a:defRPr>
+            </a:pPr>
+            <a:r>
+              <a:t>8. Click 'gpt2-finetuned.pt'</a:t>
+            </a:r>
+          </a:p>
+          <a:p>
+            <a:pPr>
+              <a:defRPr sz="950">
+                <a:solidFill>
+                  <a:srgbClr val="4B5563"/>
+                </a:solidFill>
+                <a:latin typeface="Arial"/>
+              </a:defRPr>
+            </a:pPr>
+            <a:r>
+              <a:t>Switch active model in header without losing presets</a:t>
+            </a:r>
+          </a:p>
+        </p:txBody>
+      </p:sp>
+      <p:sp>
+        <p:nvSpPr>
+          <p:cNvPr id="13" name="Rounded Rectangle 12"/>
+          <p:cNvSpPr/>
+          <p:nvPr/>
+        </p:nvSpPr>
+        <p:spPr>
+          <a:xfrm>
+            <a:off x="731520" y="5321808"/>
+            <a:ext cx="5257800" cy="868680"/>
+          </a:xfrm>
+          <a:prstGeom prst="roundRect">
+            <a:avLst/>
+          </a:prstGeom>
+          <a:solidFill>
+            <a:srgbClr val="FFFFFF"/>
+          </a:solidFill>
+          <a:ln w="12700">
+            <a:solidFill>
+              <a:srgbClr val="E5E7EB"/>
+            </a:solidFill>
+          </a:ln>
+        </p:spPr>
+        <p:style>
+          <a:lnRef idx="1">
+            <a:schemeClr val="accent1"/>
+          </a:lnRef>
+          <a:fillRef idx="3">
+            <a:schemeClr val="accent1"/>
+          </a:fillRef>
+          <a:effectRef idx="2">
+            <a:schemeClr val="accent1"/>
+          </a:effectRef>
+          <a:fontRef idx="minor">
+            <a:schemeClr val="lt1"/>
+          </a:fontRef>
+        </p:style>
+        <p:txBody>
+          <a:bodyPr rtlCol="0" anchor="ctr" wrap="square" lIns="182880" rIns="182880" tIns="109728"/>
+          <a:lstStyle/>
+          <a:p>
+            <a:pPr algn="ctr">
+              <a:defRPr sz="1100" b="1">
+                <a:solidFill>
+                  <a:srgbClr val="EF4444"/>
+                </a:solidFill>
+                <a:latin typeface="Arial"/>
+              </a:defRPr>
+            </a:pPr>
+            <a:r>
+              <a:t>9. Click '[ + Upload .pt ]'</a:t>
+            </a:r>
+          </a:p>
+          <a:p>
+            <a:pPr>
+              <a:defRPr sz="950">
+                <a:solidFill>
+                  <a:srgbClr val="4B5563"/>
+                </a:solidFill>
+                <a:latin typeface="Arial"/>
+              </a:defRPr>
+            </a:pPr>
+            <a:r>
+              <a:t>Upload custom model checkpoint placeholder</a:t>
+            </a:r>
+          </a:p>
+        </p:txBody>
+      </p:sp>
+      <p:sp>
+        <p:nvSpPr>
+          <p:cNvPr id="14" name="Rounded Rectangle 13"/>
+          <p:cNvSpPr/>
+          <p:nvPr/>
+        </p:nvSpPr>
+        <p:spPr>
+          <a:xfrm>
+            <a:off x="6172200" y="5321808"/>
+            <a:ext cx="5257800" cy="868680"/>
+          </a:xfrm>
+          <a:prstGeom prst="roundRect">
+            <a:avLst/>
+          </a:prstGeom>
+          <a:solidFill>
+            <a:srgbClr val="FFFFFF"/>
+          </a:solidFill>
+          <a:ln w="12700">
+            <a:solidFill>
+              <a:srgbClr val="E5E7EB"/>
+            </a:solidFill>
+          </a:ln>
+        </p:spPr>
+        <p:style>
+          <a:lnRef idx="1">
+            <a:schemeClr val="accent1"/>
+          </a:lnRef>
+          <a:fillRef idx="3">
+            <a:schemeClr val="accent1"/>
+          </a:fillRef>
+          <a:effectRef idx="2">
+            <a:schemeClr val="accent1"/>
+          </a:effectRef>
+          <a:fontRef idx="minor">
+            <a:schemeClr val="lt1"/>
+          </a:fontRef>
+        </p:style>
+        <p:txBody>
+          <a:bodyPr rtlCol="0" anchor="ctr" wrap="square" lIns="182880" rIns="182880" tIns="109728"/>
+          <a:lstStyle/>
+          <a:p>
+            <a:pPr algn="ctr">
+              <a:defRPr sz="1100" b="1">
+                <a:solidFill>
+                  <a:srgbClr val="EF4444"/>
+                </a:solidFill>
+                <a:latin typeface="Arial"/>
+              </a:defRPr>
+            </a:pPr>
+            <a:r>
+              <a:t>10. Click '[ Reset Baseline ]'</a:t>
+            </a:r>
+          </a:p>
+          <a:p>
+            <a:pPr>
+              <a:defRPr sz="950">
+                <a:solidFill>
+                  <a:srgbClr val="4B5563"/>
+                </a:solidFill>
+                <a:latin typeface="Arial"/>
+              </a:defRPr>
+            </a:pPr>
+            <a:r>
+              <a:t>Restore unmodified Transformer forward pass</a:t>
             </a:r>
           </a:p>
         </p:txBody>
@@ -4047,7 +6069,7 @@
         <p:spPr>
           <a:xfrm>
             <a:off x="731520" y="365760"/>
-            <a:ext cx="5486400" cy="320040"/>
+            <a:ext cx="6858000" cy="292608"/>
           </a:xfrm>
           <a:prstGeom prst="rect">
             <a:avLst/>
@@ -4063,13 +6085,13 @@
             <a:pPr>
               <a:defRPr sz="1000" b="1">
                 <a:solidFill>
-                  <a:srgbClr val="047857"/>
-                </a:solidFill>
-                <a:latin typeface="Arial"/>
-              </a:defRPr>
-            </a:pPr>
-            <a:r>
-              <a:t>STEP 1 OF 5 · USER JOURNEY</a:t>
+                  <a:srgbClr val="EF4444"/>
+                </a:solidFill>
+                <a:latin typeface="Arial"/>
+              </a:defRPr>
+            </a:pPr>
+            <a:r>
+              <a:t>STEP 1 OF 10 · RED CIRCLE: WORD PILL 'FRANCE' (POSITION 3)</a:t>
             </a:r>
           </a:p>
         </p:txBody>
@@ -4097,7 +6119,7 @@
           <a:lstStyle/>
           <a:p>
             <a:pPr>
-              <a:defRPr sz="2200" b="1">
+              <a:defRPr sz="2100" b="1">
                 <a:solidFill>
                   <a:srgbClr val="111815"/>
                 </a:solidFill>
@@ -4105,7 +6127,7 @@
               </a:defRPr>
             </a:pPr>
             <a:r>
-              <a:t>User Step 1: Zero-Setup Arrival &amp; Exploration</a:t>
+              <a:t>Step 1: Inspecting Word Meaning (The Interpreter)</a:t>
             </a:r>
           </a:p>
         </p:txBody>
@@ -4118,8 +6140,8 @@
         </p:nvSpPr>
         <p:spPr>
           <a:xfrm>
-            <a:off x="731520" y="1325880"/>
-            <a:ext cx="4114800" cy="5074920"/>
+            <a:off x="731520" y="1298448"/>
+            <a:ext cx="4114800" cy="5120640"/>
           </a:xfrm>
           <a:prstGeom prst="roundRect">
             <a:avLst/>
@@ -4148,12 +6170,28 @@
           </a:fontRef>
         </p:style>
         <p:txBody>
-          <a:bodyPr rtlCol="0" anchor="ctr" wrap="square" lIns="274320" rIns="274320" tIns="274320"/>
+          <a:bodyPr rtlCol="0" anchor="ctr" wrap="square" lIns="256032" rIns="256032" tIns="228600"/>
           <a:lstStyle/>
           <a:p>
             <a:pPr algn="ctr">
+              <a:spcAft>
+                <a:spcPts val="800"/>
+              </a:spcAft>
               <a:defRPr sz="1100" b="1">
                 <a:solidFill>
+                  <a:srgbClr val="EF4444"/>
+                </a:solidFill>
+                <a:latin typeface="Arial"/>
+              </a:defRPr>
+            </a:pPr>
+            <a:r>
+              <a:t>🔴 RED CIRCLE CLICK: Word Pill 'France' (Position 3)</a:t>
+            </a:r>
+          </a:p>
+          <a:p>
+            <a:pPr>
+              <a:defRPr sz="1050" b="1">
+                <a:solidFill>
                   <a:srgbClr val="047857"/>
                 </a:solidFill>
                 <a:latin typeface="Arial"/>
@@ -4166,7 +6204,7 @@
           <a:p>
             <a:pPr>
               <a:spcAft>
-                <a:spcPts val="1000"/>
+                <a:spcPts val="700"/>
               </a:spcAft>
               <a:defRPr sz="950">
                 <a:solidFill>
@@ -4176,12 +6214,12 @@
               </a:defRPr>
             </a:pPr>
             <a:r>
-              <a:t>I navigate directly to http://127.0.0.1:8000 in my browser.</a:t>
-            </a:r>
-          </a:p>
-          <a:p>
-            <a:pPr>
-              <a:defRPr sz="1100" b="1">
+              <a:t>I click on the word pill 'France' in the pre-loaded prompt bar.</a:t>
+            </a:r>
+          </a:p>
+          <a:p>
+            <a:pPr>
+              <a:defRPr sz="1050" b="1">
                 <a:solidFill>
                   <a:srgbClr val="047857"/>
                 </a:solidFill>
@@ -4189,13 +6227,13 @@
               </a:defRPr>
             </a:pPr>
             <a:r>
-              <a:t>What I Experience</a:t>
+              <a:t>What I See</a:t>
             </a:r>
           </a:p>
           <a:p>
             <a:pPr>
               <a:spcAft>
-                <a:spcPts val="1000"/>
+                <a:spcPts val="700"/>
               </a:spcAft>
               <a:defRPr sz="950">
                 <a:solidFill>
@@ -4205,12 +6243,12 @@
               </a:defRPr>
             </a:pPr>
             <a:r>
-              <a:t>There is no login gate, setup wizard, or blank canvas. The system boots directly into an active, live example.</a:t>
-            </a:r>
-          </a:p>
-          <a:p>
-            <a:pPr>
-              <a:defRPr sz="1100" b="1">
+              <a:t>Word pill highlights in emerald. Card 1 immediately displays the internal concept: 'Sovereign entity: French Republic (Western Europe, Eurozone, Paris hub)'.</a:t>
+            </a:r>
+          </a:p>
+          <a:p>
+            <a:pPr>
+              <a:defRPr sz="1050" b="1">
                 <a:solidFill>
                   <a:srgbClr val="047857"/>
                 </a:solidFill>
@@ -4218,13 +6256,13 @@
               </a:defRPr>
             </a:pPr>
             <a:r>
-              <a:t>Immediate Visual Feedback</a:t>
+              <a:t>Semantic Tags &amp; Strength</a:t>
             </a:r>
           </a:p>
           <a:p>
             <a:pPr>
               <a:spcAft>
-                <a:spcPts val="1000"/>
+                <a:spcPts val="700"/>
               </a:spcAft>
               <a:defRPr sz="950">
                 <a:solidFill>
@@ -4234,12 +6272,12 @@
               </a:defRPr>
             </a:pPr>
             <a:r>
-              <a:t>The prompt 'The capital of France is' is tokenized into interactive word pills. Each word is softly tinted by its internal activation intensity.</a:t>
-            </a:r>
-          </a:p>
-          <a:p>
-            <a:pPr>
-              <a:defRPr sz="1100" b="1">
+              <a:t>Displays tags ['Country', 'Europe', 'France'] with 95% activation strength.</a:t>
+            </a:r>
+          </a:p>
+          <a:p>
+            <a:pPr>
+              <a:defRPr sz="1050" b="1">
                 <a:solidFill>
                   <a:srgbClr val="047857"/>
                 </a:solidFill>
@@ -4247,13 +6285,13 @@
               </a:defRPr>
             </a:pPr>
             <a:r>
-              <a:t>2-Card Layout Simplicity</a:t>
+              <a:t>Why It Matters</a:t>
             </a:r>
           </a:p>
           <a:p>
             <a:pPr>
               <a:spcAft>
-                <a:spcPts val="1000"/>
+                <a:spcPts val="700"/>
               </a:spcAft>
               <a:defRPr sz="950">
                 <a:solidFill>
@@ -4263,36 +6301,7 @@
               </a:defRPr>
             </a:pPr>
             <a:r>
-              <a:t>I immediately see exactly two cards: '1. Interpret' on the left and '2. Steer' on the right, themed in Unsloth Studio Light sage-white.</a:t>
-            </a:r>
-          </a:p>
-          <a:p>
-            <a:pPr>
-              <a:defRPr sz="1100" b="1">
-                <a:solidFill>
-                  <a:srgbClr val="047857"/>
-                </a:solidFill>
-                <a:latin typeface="Arial"/>
-              </a:defRPr>
-            </a:pPr>
-            <a:r>
-              <a:t>Why It Matters</a:t>
-            </a:r>
-          </a:p>
-          <a:p>
-            <a:pPr>
-              <a:spcAft>
-                <a:spcPts val="1000"/>
-              </a:spcAft>
-              <a:defRPr sz="950">
-                <a:solidFill>
-                  <a:srgbClr val="4B5563"/>
-                </a:solidFill>
-                <a:latin typeface="Arial"/>
-              </a:defRPr>
-            </a:pPr>
-            <a:r>
-              <a:t>Researchers can inspect neural activations in seconds without configuring models, SAE dictionary sizes, or GPU device drivers.</a:t>
+              <a:t>Researchers immediately read internal meaning in human English without interpreting neuron indices or activation histograms.</a:t>
             </a:r>
           </a:p>
         </p:txBody>
@@ -4305,8 +6314,8 @@
         </p:nvSpPr>
         <p:spPr>
           <a:xfrm>
-            <a:off x="5029200" y="1325880"/>
-            <a:ext cx="6430975" cy="5074920"/>
+            <a:off x="5010912" y="1298448"/>
+            <a:ext cx="6446520" cy="5120640"/>
           </a:xfrm>
           <a:prstGeom prst="roundRect">
             <a:avLst/>
@@ -4344,7 +6353,7 @@
       </p:sp>
       <p:pic>
         <p:nvPicPr>
-          <p:cNvPr id="7" name="Picture 6" descr="slide1_initial_arrival.png"/>
+          <p:cNvPr id="7" name="Picture 6" descr="step1_click_token_france.png"/>
           <p:cNvPicPr>
             <a:picLocks noChangeAspect="1"/>
           </p:cNvPicPr>
@@ -4358,8 +6367,8 @@
         </p:blipFill>
         <p:spPr>
           <a:xfrm>
-            <a:off x="5138928" y="1435608"/>
-            <a:ext cx="6208776" cy="4855464"/>
+            <a:off x="5120640" y="1408176"/>
+            <a:ext cx="6227064" cy="4901184"/>
           </a:xfrm>
           <a:prstGeom prst="rect">
             <a:avLst/>
@@ -4438,7 +6447,7 @@
         <p:spPr>
           <a:xfrm>
             <a:off x="731520" y="365760"/>
-            <a:ext cx="5486400" cy="320040"/>
+            <a:ext cx="6858000" cy="292608"/>
           </a:xfrm>
           <a:prstGeom prst="rect">
             <a:avLst/>
@@ -4454,13 +6463,13 @@
             <a:pPr>
               <a:defRPr sz="1000" b="1">
                 <a:solidFill>
-                  <a:srgbClr val="047857"/>
-                </a:solidFill>
-                <a:latin typeface="Arial"/>
-              </a:defRPr>
-            </a:pPr>
-            <a:r>
-              <a:t>STEP 2 OF 5 · USER JOURNEY</a:t>
+                  <a:srgbClr val="EF4444"/>
+                </a:solidFill>
+                <a:latin typeface="Arial"/>
+              </a:defRPr>
+            </a:pPr>
+            <a:r>
+              <a:t>STEP 2 OF 10 · RED CIRCLE: BUTTON '⚡ STEER THIS CONCEPT IN CARD 2'</a:t>
             </a:r>
           </a:p>
         </p:txBody>
@@ -4488,7 +6497,7 @@
           <a:lstStyle/>
           <a:p>
             <a:pPr>
-              <a:defRPr sz="2200" b="1">
+              <a:defRPr sz="2100" b="1">
                 <a:solidFill>
                   <a:srgbClr val="111815"/>
                 </a:solidFill>
@@ -4496,7 +6505,7 @@
               </a:defRPr>
             </a:pPr>
             <a:r>
-              <a:t>User Step 2: The Interpreter — Reading Internal Meaning</a:t>
+              <a:t>Step 2: Bridging Interpretation to Steering</a:t>
             </a:r>
           </a:p>
         </p:txBody>
@@ -4509,8 +6518,8 @@
         </p:nvSpPr>
         <p:spPr>
           <a:xfrm>
-            <a:off x="731520" y="1325880"/>
-            <a:ext cx="4114800" cy="5074920"/>
+            <a:off x="731520" y="1298448"/>
+            <a:ext cx="4114800" cy="5120640"/>
           </a:xfrm>
           <a:prstGeom prst="roundRect">
             <a:avLst/>
@@ -4539,12 +6548,28 @@
           </a:fontRef>
         </p:style>
         <p:txBody>
-          <a:bodyPr rtlCol="0" anchor="ctr" wrap="square" lIns="274320" rIns="274320" tIns="274320"/>
+          <a:bodyPr rtlCol="0" anchor="ctr" wrap="square" lIns="256032" rIns="256032" tIns="228600"/>
           <a:lstStyle/>
           <a:p>
             <a:pPr algn="ctr">
+              <a:spcAft>
+                <a:spcPts val="800"/>
+              </a:spcAft>
               <a:defRPr sz="1100" b="1">
                 <a:solidFill>
+                  <a:srgbClr val="EF4444"/>
+                </a:solidFill>
+                <a:latin typeface="Arial"/>
+              </a:defRPr>
+            </a:pPr>
+            <a:r>
+              <a:t>🔴 RED CIRCLE CLICK: Button '⚡ Steer This Concept in Card 2'</a:t>
+            </a:r>
+          </a:p>
+          <a:p>
+            <a:pPr>
+              <a:defRPr sz="1050" b="1">
+                <a:solidFill>
                   <a:srgbClr val="047857"/>
                 </a:solidFill>
                 <a:latin typeface="Arial"/>
@@ -4557,7 +6582,7 @@
           <a:p>
             <a:pPr>
               <a:spcAft>
-                <a:spcPts val="1000"/>
+                <a:spcPts val="700"/>
               </a:spcAft>
               <a:defRPr sz="950">
                 <a:solidFill>
@@ -4567,12 +6592,12 @@
               </a:defRPr>
             </a:pPr>
             <a:r>
-              <a:t>I click the word pill 'France' (Position 3) in the prompt bar.</a:t>
-            </a:r>
-          </a:p>
-          <a:p>
-            <a:pPr>
-              <a:defRPr sz="1100" b="1">
+              <a:t>In Card 1, I click the green quick-action button '⚡ Steer This Concept in Card 2'.</a:t>
+            </a:r>
+          </a:p>
+          <a:p>
+            <a:pPr>
+              <a:defRPr sz="1050" b="1">
                 <a:solidFill>
                   <a:srgbClr val="047857"/>
                 </a:solidFill>
@@ -4580,13 +6605,13 @@
               </a:defRPr>
             </a:pPr>
             <a:r>
-              <a:t>What I Experience</a:t>
+              <a:t>What I See</a:t>
             </a:r>
           </a:p>
           <a:p>
             <a:pPr>
               <a:spcAft>
-                <a:spcPts val="1000"/>
+                <a:spcPts val="700"/>
               </a:spcAft>
               <a:defRPr sz="950">
                 <a:solidFill>
@@ -4596,12 +6621,12 @@
               </a:defRPr>
             </a:pPr>
             <a:r>
-              <a:t>Card 1 ('1. Interpret') updates instantly to show the plain-English firing concept: 'Sovereign entity: French Republic (Western Europe, Eurozone, Paris hub)'.</a:t>
-            </a:r>
-          </a:p>
-          <a:p>
-            <a:pPr>
-              <a:defRPr sz="1100" b="1">
+              <a:t>The concept description is copied straight into the Card 2 concept input, and a confirmation toast appears: 'Concept copied to Steer card'.</a:t>
+            </a:r>
+          </a:p>
+          <a:p>
+            <a:pPr>
+              <a:defRPr sz="1050" b="1">
                 <a:solidFill>
                   <a:srgbClr val="047857"/>
                 </a:solidFill>
@@ -4609,13 +6634,13 @@
               </a:defRPr>
             </a:pPr>
             <a:r>
-              <a:t>Human-Interpretable Tags</a:t>
+              <a:t>Seamless Interaction</a:t>
             </a:r>
           </a:p>
           <a:p>
             <a:pPr>
               <a:spcAft>
-                <a:spcPts val="1000"/>
+                <a:spcPts val="700"/>
               </a:spcAft>
               <a:defRPr sz="950">
                 <a:solidFill>
@@ -4625,12 +6650,12 @@
               </a:defRPr>
             </a:pPr>
             <a:r>
-              <a:t>The concept displays semantic tags: ['Country', 'Europe', 'France'] with 95% activation strength.</a:t>
-            </a:r>
-          </a:p>
-          <a:p>
-            <a:pPr>
-              <a:defRPr sz="1100" b="1">
+              <a:t>Eliminates tedious manual copy-pasting or re-typing between explanation and steering.</a:t>
+            </a:r>
+          </a:p>
+          <a:p>
+            <a:pPr>
+              <a:defRPr sz="1050" b="1">
                 <a:solidFill>
                   <a:srgbClr val="047857"/>
                 </a:solidFill>
@@ -4638,13 +6663,13 @@
               </a:defRPr>
             </a:pPr>
             <a:r>
-              <a:t>Zero Mechanistic Jargon</a:t>
+              <a:t>Why It Matters</a:t>
             </a:r>
           </a:p>
           <a:p>
             <a:pPr>
               <a:spcAft>
-                <a:spcPts val="1000"/>
+                <a:spcPts val="700"/>
               </a:spcAft>
               <a:defRPr sz="950">
                 <a:solidFill>
@@ -4654,36 +6679,7 @@
               </a:defRPr>
             </a:pPr>
             <a:r>
-              <a:t>I am not confronted with obscure neuron IDs like 'L8·N14209', activation histograms, or logit tables.</a:t>
-            </a:r>
-          </a:p>
-          <a:p>
-            <a:pPr>
-              <a:defRPr sz="1100" b="1">
-                <a:solidFill>
-                  <a:srgbClr val="047857"/>
-                </a:solidFill>
-                <a:latin typeface="Arial"/>
-              </a:defRPr>
-            </a:pPr>
-            <a:r>
-              <a:t>Actionable Next Step</a:t>
-            </a:r>
-          </a:p>
-          <a:p>
-            <a:pPr>
-              <a:spcAft>
-                <a:spcPts val="1000"/>
-              </a:spcAft>
-              <a:defRPr sz="950">
-                <a:solidFill>
-                  <a:srgbClr val="4B5563"/>
-                </a:solidFill>
-                <a:latin typeface="Arial"/>
-              </a:defRPr>
-            </a:pPr>
-            <a:r>
-              <a:t>A single-click button '⚡ Steer This Concept in Card 2' bridges interpretation directly to causal intervention.</a:t>
+              <a:t>Enables rapid hypothesis formulation: inspect a concept, then immediately test what happens if you steer it.</a:t>
             </a:r>
           </a:p>
         </p:txBody>
@@ -4696,8 +6692,8 @@
         </p:nvSpPr>
         <p:spPr>
           <a:xfrm>
-            <a:off x="5029200" y="1325880"/>
-            <a:ext cx="6430975" cy="5074920"/>
+            <a:off x="5010912" y="1298448"/>
+            <a:ext cx="6446520" cy="5120640"/>
           </a:xfrm>
           <a:prstGeom prst="roundRect">
             <a:avLst/>
@@ -4735,7 +6731,7 @@
       </p:sp>
       <p:pic>
         <p:nvPicPr>
-          <p:cNvPr id="7" name="Picture 6" descr="slide2_token_inspection.png"/>
+          <p:cNvPr id="7" name="Picture 6" descr="step2_click_steer_this_concept.png"/>
           <p:cNvPicPr>
             <a:picLocks noChangeAspect="1"/>
           </p:cNvPicPr>
@@ -4749,8 +6745,8 @@
         </p:blipFill>
         <p:spPr>
           <a:xfrm>
-            <a:off x="5138928" y="1435608"/>
-            <a:ext cx="6208776" cy="4855464"/>
+            <a:off x="5120640" y="1408176"/>
+            <a:ext cx="6227064" cy="4901184"/>
           </a:xfrm>
           <a:prstGeom prst="rect">
             <a:avLst/>
@@ -4829,7 +6825,7 @@
         <p:spPr>
           <a:xfrm>
             <a:off x="731520" y="365760"/>
-            <a:ext cx="5486400" cy="320040"/>
+            <a:ext cx="6858000" cy="292608"/>
           </a:xfrm>
           <a:prstGeom prst="rect">
             <a:avLst/>
@@ -4845,13 +6841,13 @@
             <a:pPr>
               <a:defRPr sz="1000" b="1">
                 <a:solidFill>
-                  <a:srgbClr val="047857"/>
-                </a:solidFill>
-                <a:latin typeface="Arial"/>
-              </a:defRPr>
-            </a:pPr>
-            <a:r>
-              <a:t>STEP 3 OF 5 · USER JOURNEY</a:t>
+                  <a:srgbClr val="EF4444"/>
+                </a:solidFill>
+                <a:latin typeface="Arial"/>
+              </a:defRPr>
+            </a:pPr>
+            <a:r>
+              <a:t>STEP 3 OF 10 · RED CIRCLE: WORD PILL 'IS' (POSITION 4)</a:t>
             </a:r>
           </a:p>
         </p:txBody>
@@ -4879,7 +6875,7 @@
           <a:lstStyle/>
           <a:p>
             <a:pPr>
-              <a:defRPr sz="2200" b="1">
+              <a:defRPr sz="2100" b="1">
                 <a:solidFill>
                   <a:srgbClr val="111815"/>
                 </a:solidFill>
@@ -4887,7 +6883,7 @@
               </a:defRPr>
             </a:pPr>
             <a:r>
-              <a:t>User Step 3: The Steerer — Causal Interventions Side-by-Side</a:t>
+              <a:t>Step 3: Focusing on the Prediction Node</a:t>
             </a:r>
           </a:p>
         </p:txBody>
@@ -4900,8 +6896,8 @@
         </p:nvSpPr>
         <p:spPr>
           <a:xfrm>
-            <a:off x="731520" y="1325880"/>
-            <a:ext cx="4114800" cy="5074920"/>
+            <a:off x="731520" y="1298448"/>
+            <a:ext cx="4114800" cy="5120640"/>
           </a:xfrm>
           <a:prstGeom prst="roundRect">
             <a:avLst/>
@@ -4930,12 +6926,28 @@
           </a:fontRef>
         </p:style>
         <p:txBody>
-          <a:bodyPr rtlCol="0" anchor="ctr" wrap="square" lIns="274320" rIns="274320" tIns="274320"/>
+          <a:bodyPr rtlCol="0" anchor="ctr" wrap="square" lIns="256032" rIns="256032" tIns="228600"/>
           <a:lstStyle/>
           <a:p>
             <a:pPr algn="ctr">
+              <a:spcAft>
+                <a:spcPts val="800"/>
+              </a:spcAft>
               <a:defRPr sz="1100" b="1">
                 <a:solidFill>
+                  <a:srgbClr val="EF4444"/>
+                </a:solidFill>
+                <a:latin typeface="Arial"/>
+              </a:defRPr>
+            </a:pPr>
+            <a:r>
+              <a:t>🔴 RED CIRCLE CLICK: Word Pill 'is' (Position 4)</a:t>
+            </a:r>
+          </a:p>
+          <a:p>
+            <a:pPr>
+              <a:defRPr sz="1050" b="1">
+                <a:solidFill>
                   <a:srgbClr val="047857"/>
                 </a:solidFill>
                 <a:latin typeface="Arial"/>
@@ -4948,7 +6960,7 @@
           <a:p>
             <a:pPr>
               <a:spcAft>
-                <a:spcPts val="1000"/>
+                <a:spcPts val="700"/>
               </a:spcAft>
               <a:defRPr sz="950">
                 <a:solidFill>
@@ -4958,12 +6970,12 @@
               </a:defRPr>
             </a:pPr>
             <a:r>
-              <a:t>I select token 'is' and click the '📌 Tokyo Steer' preset pill with Boost mode at 1.00x intensity.</a:t>
-            </a:r>
-          </a:p>
-          <a:p>
-            <a:pPr>
-              <a:defRPr sz="1100" b="1">
+              <a:t>I click on the word pill 'is' (Position 4) right before the model produces the answer.</a:t>
+            </a:r>
+          </a:p>
+          <a:p>
+            <a:pPr>
+              <a:defRPr sz="1050" b="1">
                 <a:solidFill>
                   <a:srgbClr val="047857"/>
                 </a:solidFill>
@@ -4971,13 +6983,13 @@
               </a:defRPr>
             </a:pPr>
             <a:r>
-              <a:t>What I Experience</a:t>
+              <a:t>What I See</a:t>
             </a:r>
           </a:p>
           <a:p>
             <a:pPr>
               <a:spcAft>
-                <a:spcPts val="1000"/>
+                <a:spcPts val="700"/>
               </a:spcAft>
               <a:defRPr sz="950">
                 <a:solidFill>
@@ -4987,12 +6999,12 @@
               </a:defRPr>
             </a:pPr>
             <a:r>
-              <a:t>Card 2 ('2. Steer') renders a side-by-side comparison of Default vs. Steered model outputs.</a:t>
-            </a:r>
-          </a:p>
-          <a:p>
-            <a:pPr>
-              <a:defRPr sz="1100" b="1">
+              <a:t>Card 1 updates to show: 'Predicting Paris as the capital city of France' with 99% activation strength.</a:t>
+            </a:r>
+          </a:p>
+          <a:p>
+            <a:pPr>
+              <a:defRPr sz="1050" b="1">
                 <a:solidFill>
                   <a:srgbClr val="047857"/>
                 </a:solidFill>
@@ -5000,13 +7012,13 @@
               </a:defRPr>
             </a:pPr>
             <a:r>
-              <a:t>Default Output</a:t>
+              <a:t>Mechanistic Insight</a:t>
             </a:r>
           </a:p>
           <a:p>
             <a:pPr>
               <a:spcAft>
-                <a:spcPts val="1000"/>
+                <a:spcPts val="700"/>
               </a:spcAft>
               <a:defRPr sz="950">
                 <a:solidFill>
@@ -5016,12 +7028,12 @@
               </a:defRPr>
             </a:pPr>
             <a:r>
-              <a:t>'The capital of France is Paris, the country's most populous city.'</a:t>
-            </a:r>
-          </a:p>
-          <a:p>
-            <a:pPr>
-              <a:defRPr sz="1100" b="1">
+              <a:t>The model has gathered entity representations and is now actively retrieving the capital city token 'Paris'.</a:t>
+            </a:r>
+          </a:p>
+          <a:p>
+            <a:pPr>
+              <a:defRPr sz="1050" b="1">
                 <a:solidFill>
                   <a:srgbClr val="047857"/>
                 </a:solidFill>
@@ -5029,13 +7041,13 @@
               </a:defRPr>
             </a:pPr>
             <a:r>
-              <a:t>Steered Output</a:t>
+              <a:t>Why It Matters</a:t>
             </a:r>
           </a:p>
           <a:p>
             <a:pPr>
               <a:spcAft>
-                <a:spcPts val="1000"/>
+                <a:spcPts val="700"/>
               </a:spcAft>
               <a:defRPr sz="950">
                 <a:solidFill>
@@ -5045,36 +7057,7 @@
               </a:defRPr>
             </a:pPr>
             <a:r>
-              <a:t>'The capital of France is Tokyo, in an alternate world where Japan and France united.'</a:t>
-            </a:r>
-          </a:p>
-          <a:p>
-            <a:pPr>
-              <a:defRPr sz="1100" b="1">
-                <a:solidFill>
-                  <a:srgbClr val="047857"/>
-                </a:solidFill>
-                <a:latin typeface="Arial"/>
-              </a:defRPr>
-            </a:pPr>
-            <a:r>
-              <a:t>Diff Explanation Banner</a:t>
-            </a:r>
-          </a:p>
-          <a:p>
-            <a:pPr>
-              <a:spcAft>
-                <a:spcPts val="1000"/>
-              </a:spcAft>
-              <a:defRPr sz="950">
-                <a:solidFill>
-                  <a:srgbClr val="4B5563"/>
-                </a:solidFill>
-                <a:latin typeface="Arial"/>
-              </a:defRPr>
-            </a:pPr>
-            <a:r>
-              <a:t>The system provides an exact explanation: 'Replaced Paris fact retrieval with Tokyo / Japan entity representation'.</a:t>
+              <a:t>Identifies the exact causal decision point where the model commits to its factual output.</a:t>
             </a:r>
           </a:p>
         </p:txBody>
@@ -5087,8 +7070,8 @@
         </p:nvSpPr>
         <p:spPr>
           <a:xfrm>
-            <a:off x="5029200" y="1325880"/>
-            <a:ext cx="6430975" cy="5074920"/>
+            <a:off x="5010912" y="1298448"/>
+            <a:ext cx="6446520" cy="5120640"/>
           </a:xfrm>
           <a:prstGeom prst="roundRect">
             <a:avLst/>
@@ -5126,7 +7109,7 @@
       </p:sp>
       <p:pic>
         <p:nvPicPr>
-          <p:cNvPr id="7" name="Picture 6" descr="slide3_causal_steering.png"/>
+          <p:cNvPr id="7" name="Picture 6" descr="step3_click_token_is.png"/>
           <p:cNvPicPr>
             <a:picLocks noChangeAspect="1"/>
           </p:cNvPicPr>
@@ -5140,8 +7123,8 @@
         </p:blipFill>
         <p:spPr>
           <a:xfrm>
-            <a:off x="5138928" y="1435608"/>
-            <a:ext cx="6208776" cy="4855464"/>
+            <a:off x="5120640" y="1408176"/>
+            <a:ext cx="6227064" cy="4901184"/>
           </a:xfrm>
           <a:prstGeom prst="rect">
             <a:avLst/>
@@ -5220,7 +7203,7 @@
         <p:spPr>
           <a:xfrm>
             <a:off x="731520" y="365760"/>
-            <a:ext cx="5486400" cy="320040"/>
+            <a:ext cx="6858000" cy="292608"/>
           </a:xfrm>
           <a:prstGeom prst="rect">
             <a:avLst/>
@@ -5236,13 +7219,13 @@
             <a:pPr>
               <a:defRPr sz="1000" b="1">
                 <a:solidFill>
-                  <a:srgbClr val="047857"/>
-                </a:solidFill>
-                <a:latin typeface="Arial"/>
-              </a:defRPr>
-            </a:pPr>
-            <a:r>
-              <a:t>STEP 4 OF 5 · USER JOURNEY</a:t>
+                  <a:srgbClr val="EF4444"/>
+                </a:solidFill>
+                <a:latin typeface="Arial"/>
+              </a:defRPr>
+            </a:pPr>
+            <a:r>
+              <a:t>STEP 4 OF 10 · RED CIRCLE: PRESET PILL '📌 TOKYO STEER'</a:t>
             </a:r>
           </a:p>
         </p:txBody>
@@ -5270,7 +7253,7 @@
           <a:lstStyle/>
           <a:p>
             <a:pPr>
-              <a:defRPr sz="2200" b="1">
+              <a:defRPr sz="2100" b="1">
                 <a:solidFill>
                   <a:srgbClr val="111815"/>
                 </a:solidFill>
@@ -5278,7 +7261,7 @@
               </a:defRPr>
             </a:pPr>
             <a:r>
-              <a:t>User Step 4: Suppressing Thoughts &amp; Saving Presets</a:t>
+              <a:t>Step 4: Selecting a Counterfactual Steer Preset</a:t>
             </a:r>
           </a:p>
         </p:txBody>
@@ -5291,8 +7274,8 @@
         </p:nvSpPr>
         <p:spPr>
           <a:xfrm>
-            <a:off x="731520" y="1325880"/>
-            <a:ext cx="4114800" cy="5074920"/>
+            <a:off x="731520" y="1298448"/>
+            <a:ext cx="4114800" cy="5120640"/>
           </a:xfrm>
           <a:prstGeom prst="roundRect">
             <a:avLst/>
@@ -5321,12 +7304,28 @@
           </a:fontRef>
         </p:style>
         <p:txBody>
-          <a:bodyPr rtlCol="0" anchor="ctr" wrap="square" lIns="274320" rIns="274320" tIns="274320"/>
+          <a:bodyPr rtlCol="0" anchor="ctr" wrap="square" lIns="256032" rIns="256032" tIns="228600"/>
           <a:lstStyle/>
           <a:p>
             <a:pPr algn="ctr">
+              <a:spcAft>
+                <a:spcPts val="800"/>
+              </a:spcAft>
               <a:defRPr sz="1100" b="1">
                 <a:solidFill>
+                  <a:srgbClr val="EF4444"/>
+                </a:solidFill>
+                <a:latin typeface="Arial"/>
+              </a:defRPr>
+            </a:pPr>
+            <a:r>
+              <a:t>🔴 RED CIRCLE CLICK: Preset Pill '📌 Tokyo Steer'</a:t>
+            </a:r>
+          </a:p>
+          <a:p>
+            <a:pPr>
+              <a:defRPr sz="1050" b="1">
+                <a:solidFill>
                   <a:srgbClr val="047857"/>
                 </a:solidFill>
                 <a:latin typeface="Arial"/>
@@ -5339,7 +7338,7 @@
           <a:p>
             <a:pPr>
               <a:spcAft>
-                <a:spcPts val="1000"/>
+                <a:spcPts val="700"/>
               </a:spcAft>
               <a:defRPr sz="950">
                 <a:solidFill>
@@ -5349,12 +7348,12 @@
               </a:defRPr>
             </a:pPr>
             <a:r>
-              <a:t>I click '🚫 Suppress Paris' to inhibit the factual retrieval neuron cluster.</a:t>
-            </a:r>
-          </a:p>
-          <a:p>
-            <a:pPr>
-              <a:defRPr sz="1100" b="1">
+              <a:t>In Card 2, I click the saved preset pill '📌 Tokyo Steer'.</a:t>
+            </a:r>
+          </a:p>
+          <a:p>
+            <a:pPr>
+              <a:defRPr sz="1050" b="1">
                 <a:solidFill>
                   <a:srgbClr val="047857"/>
                 </a:solidFill>
@@ -5362,13 +7361,13 @@
               </a:defRPr>
             </a:pPr>
             <a:r>
-              <a:t>What I Experience</a:t>
+              <a:t>What I See</a:t>
             </a:r>
           </a:p>
           <a:p>
             <a:pPr>
               <a:spcAft>
-                <a:spcPts val="1000"/>
+                <a:spcPts val="700"/>
               </a:spcAft>
               <a:defRPr sz="950">
                 <a:solidFill>
@@ -5378,12 +7377,12 @@
               </a:defRPr>
             </a:pPr>
             <a:r>
-              <a:t>The model output immediately pivots to: 'The capital of France is a historic European city renowned for culture and architecture.'</a:t>
-            </a:r>
-          </a:p>
-          <a:p>
-            <a:pPr>
-              <a:defRPr sz="1100" b="1">
+              <a:t>Concept input changes to 'Tokyo / Japan', slider sets to 1.00x Boost, and the intervention executes instantly.</a:t>
+            </a:r>
+          </a:p>
+          <a:p>
+            <a:pPr>
+              <a:defRPr sz="1050" b="1">
                 <a:solidFill>
                   <a:srgbClr val="047857"/>
                 </a:solidFill>
@@ -5391,13 +7390,13 @@
               </a:defRPr>
             </a:pPr>
             <a:r>
-              <a:t>Factual Fallback Observation</a:t>
+              <a:t>Toast Feedback</a:t>
             </a:r>
           </a:p>
           <a:p>
             <a:pPr>
               <a:spcAft>
-                <a:spcPts val="1000"/>
+                <a:spcPts val="700"/>
               </a:spcAft>
               <a:defRPr sz="950">
                 <a:solidFill>
@@ -5407,12 +7406,12 @@
               </a:defRPr>
             </a:pPr>
             <a:r>
-              <a:t>Suppression successfully eliminates the exact token 'Paris' while allowing the Transformer to retain coherent grammatical context.</a:t>
-            </a:r>
-          </a:p>
-          <a:p>
-            <a:pPr>
-              <a:defRPr sz="1100" b="1">
+              <a:t>A notification confirms: 'Applied steer: Tokyo / Japan'.</a:t>
+            </a:r>
+          </a:p>
+          <a:p>
+            <a:pPr>
+              <a:defRPr sz="1050" b="1">
                 <a:solidFill>
                   <a:srgbClr val="047857"/>
                 </a:solidFill>
@@ -5420,13 +7419,13 @@
               </a:defRPr>
             </a:pPr>
             <a:r>
-              <a:t>Saving Steering Vectors</a:t>
+              <a:t>Why It Matters</a:t>
             </a:r>
           </a:p>
           <a:p>
             <a:pPr>
               <a:spcAft>
-                <a:spcPts val="1000"/>
+                <a:spcPts val="700"/>
               </a:spcAft>
               <a:defRPr sz="950">
                 <a:solidFill>
@@ -5436,36 +7435,7 @@
               </a:defRPr>
             </a:pPr>
             <a:r>
-              <a:t>I click 'Save Steer' to store customized interventions as reusable preset pills inside Card 2.</a:t>
-            </a:r>
-          </a:p>
-          <a:p>
-            <a:pPr>
-              <a:defRPr sz="1100" b="1">
-                <a:solidFill>
-                  <a:srgbClr val="047857"/>
-                </a:solidFill>
-                <a:latin typeface="Arial"/>
-              </a:defRPr>
-            </a:pPr>
-            <a:r>
-              <a:t>Why It Matters</a:t>
-            </a:r>
-          </a:p>
-          <a:p>
-            <a:pPr>
-              <a:spcAft>
-                <a:spcPts val="1000"/>
-              </a:spcAft>
-              <a:defRPr sz="950">
-                <a:solidFill>
-                  <a:srgbClr val="4B5563"/>
-                </a:solidFill>
-                <a:latin typeface="Arial"/>
-              </a:defRPr>
-            </a:pPr>
-            <a:r>
-              <a:t>Causal safety researchers can test concept suppression without writing PyTorch forward hooks manually.</a:t>
+              <a:t>Presets allow one-click testing of established vectors without configuring sliders from scratch.</a:t>
             </a:r>
           </a:p>
         </p:txBody>
@@ -5478,8 +7448,8 @@
         </p:nvSpPr>
         <p:spPr>
           <a:xfrm>
-            <a:off x="5029200" y="1325880"/>
-            <a:ext cx="6430975" cy="5074920"/>
+            <a:off x="5010912" y="1298448"/>
+            <a:ext cx="6446520" cy="5120640"/>
           </a:xfrm>
           <a:prstGeom prst="roundRect">
             <a:avLst/>
@@ -5517,7 +7487,7 @@
       </p:sp>
       <p:pic>
         <p:nvPicPr>
-          <p:cNvPr id="7" name="Picture 6" descr="slide4_suppress_thought.png"/>
+          <p:cNvPr id="7" name="Picture 6" descr="step4_click_tokyo_steer.png"/>
           <p:cNvPicPr>
             <a:picLocks noChangeAspect="1"/>
           </p:cNvPicPr>
@@ -5531,8 +7501,8 @@
         </p:blipFill>
         <p:spPr>
           <a:xfrm>
-            <a:off x="5138928" y="1435608"/>
-            <a:ext cx="6208776" cy="4855464"/>
+            <a:off x="5120640" y="1408176"/>
+            <a:ext cx="6227064" cy="4901184"/>
           </a:xfrm>
           <a:prstGeom prst="rect">
             <a:avLst/>
@@ -5611,7 +7581,7 @@
         <p:spPr>
           <a:xfrm>
             <a:off x="731520" y="365760"/>
-            <a:ext cx="5486400" cy="320040"/>
+            <a:ext cx="6858000" cy="292608"/>
           </a:xfrm>
           <a:prstGeom prst="rect">
             <a:avLst/>
@@ -5627,13 +7597,13 @@
             <a:pPr>
               <a:defRPr sz="1000" b="1">
                 <a:solidFill>
-                  <a:srgbClr val="047857"/>
-                </a:solidFill>
-                <a:latin typeface="Arial"/>
-              </a:defRPr>
-            </a:pPr>
-            <a:r>
-              <a:t>STEP 5 OF 5 · USER JOURNEY</a:t>
+                  <a:srgbClr val="EF4444"/>
+                </a:solidFill>
+                <a:latin typeface="Arial"/>
+              </a:defRPr>
+            </a:pPr>
+            <a:r>
+              <a:t>STEP 5 OF 10 · RED CIRCLE: PRIMARY BUTTON [ APPLY STEER ]</a:t>
             </a:r>
           </a:p>
         </p:txBody>
@@ -5661,7 +7631,7 @@
           <a:lstStyle/>
           <a:p>
             <a:pPr>
-              <a:defRPr sz="2200" b="1">
+              <a:defRPr sz="2100" b="1">
                 <a:solidFill>
                   <a:srgbClr val="111815"/>
                 </a:solidFill>
@@ -5669,7 +7639,7 @@
               </a:defRPr>
             </a:pPr>
             <a:r>
-              <a:t>User Step 5: Cross-Model Checkpoint Switching</a:t>
+              <a:t>Step 5: Inspecting Side-by-Side Steered Output</a:t>
             </a:r>
           </a:p>
         </p:txBody>
@@ -5682,8 +7652,8 @@
         </p:nvSpPr>
         <p:spPr>
           <a:xfrm>
-            <a:off x="731520" y="1325880"/>
-            <a:ext cx="4114800" cy="5074920"/>
+            <a:off x="731520" y="1298448"/>
+            <a:ext cx="4114800" cy="5120640"/>
           </a:xfrm>
           <a:prstGeom prst="roundRect">
             <a:avLst/>
@@ -5712,12 +7682,28 @@
           </a:fontRef>
         </p:style>
         <p:txBody>
-          <a:bodyPr rtlCol="0" anchor="ctr" wrap="square" lIns="274320" rIns="274320" tIns="274320"/>
+          <a:bodyPr rtlCol="0" anchor="ctr" wrap="square" lIns="256032" rIns="256032" tIns="228600"/>
           <a:lstStyle/>
           <a:p>
             <a:pPr algn="ctr">
+              <a:spcAft>
+                <a:spcPts val="800"/>
+              </a:spcAft>
               <a:defRPr sz="1100" b="1">
                 <a:solidFill>
+                  <a:srgbClr val="EF4444"/>
+                </a:solidFill>
+                <a:latin typeface="Arial"/>
+              </a:defRPr>
+            </a:pPr>
+            <a:r>
+              <a:t>🔴 RED CIRCLE CLICK: Primary Button [ Apply Steer ]</a:t>
+            </a:r>
+          </a:p>
+          <a:p>
+            <a:pPr>
+              <a:defRPr sz="1050" b="1">
+                <a:solidFill>
                   <a:srgbClr val="047857"/>
                 </a:solidFill>
                 <a:latin typeface="Arial"/>
@@ -5730,7 +7716,7 @@
           <a:p>
             <a:pPr>
               <a:spcAft>
-                <a:spcPts val="1000"/>
+                <a:spcPts val="700"/>
               </a:spcAft>
               <a:defRPr sz="950">
                 <a:solidFill>
@@ -5740,12 +7726,12 @@
               </a:defRPr>
             </a:pPr>
             <a:r>
-              <a:t>In the top header, I click 'gpt2-finetuned.pt' (or use '+ Upload .pt' to load new weights).</a:t>
-            </a:r>
-          </a:p>
-          <a:p>
-            <a:pPr>
-              <a:defRPr sz="1100" b="1">
+              <a:t>I click '[ Apply Steer ]' after fine-tuning intensity.</a:t>
+            </a:r>
+          </a:p>
+          <a:p>
+            <a:pPr>
+              <a:defRPr sz="1050" b="1">
                 <a:solidFill>
                   <a:srgbClr val="047857"/>
                 </a:solidFill>
@@ -5753,13 +7739,13 @@
               </a:defRPr>
             </a:pPr>
             <a:r>
-              <a:t>What I Experience</a:t>
+              <a:t>What I See Side-by-Side</a:t>
             </a:r>
           </a:p>
           <a:p>
             <a:pPr>
               <a:spcAft>
-                <a:spcPts val="1000"/>
+                <a:spcPts val="700"/>
               </a:spcAft>
               <a:defRPr sz="950">
                 <a:solidFill>
@@ -5769,12 +7755,16 @@
               </a:defRPr>
             </a:pPr>
             <a:r>
-              <a:t>The active model switches immediately without reloading the page or losing current session context.</a:t>
-            </a:r>
-          </a:p>
-          <a:p>
-            <a:pPr>
-              <a:defRPr sz="1100" b="1">
+              <a:t>• Default Output: 'The capital of France is Paris, the country's most populous city.'</a:t>
+            </a:r>
+            <a:br/>
+            <a:r>
+              <a:t>• Steered Output: 'The capital of France is Tokyo, in an alternate world where Japan and France united.'</a:t>
+            </a:r>
+          </a:p>
+          <a:p>
+            <a:pPr>
+              <a:defRPr sz="1050" b="1">
                 <a:solidFill>
                   <a:srgbClr val="047857"/>
                 </a:solidFill>
@@ -5782,13 +7772,13 @@
               </a:defRPr>
             </a:pPr>
             <a:r>
-              <a:t>Preserved Steering Presets</a:t>
+              <a:t>Diff Explanation Banner</a:t>
             </a:r>
           </a:p>
           <a:p>
             <a:pPr>
               <a:spcAft>
-                <a:spcPts val="1000"/>
+                <a:spcPts val="700"/>
               </a:spcAft>
               <a:defRPr sz="950">
                 <a:solidFill>
@@ -5798,12 +7788,12 @@
               </a:defRPr>
             </a:pPr>
             <a:r>
-              <a:t>All saved steer presets (Tokyo, Berlin, Suppress Paris) remain clickable inside Card 2.</a:t>
-            </a:r>
-          </a:p>
-          <a:p>
-            <a:pPr>
-              <a:defRPr sz="1100" b="1">
+              <a:t>'Replaced Paris fact retrieval with Tokyo / Japan entity representation'.</a:t>
+            </a:r>
+          </a:p>
+          <a:p>
+            <a:pPr>
+              <a:defRPr sz="1050" b="1">
                 <a:solidFill>
                   <a:srgbClr val="047857"/>
                 </a:solidFill>
@@ -5811,13 +7801,13 @@
               </a:defRPr>
             </a:pPr>
             <a:r>
-              <a:t>Cross-Model Validation</a:t>
+              <a:t>Why It Matters</a:t>
             </a:r>
           </a:p>
           <a:p>
             <a:pPr>
               <a:spcAft>
-                <a:spcPts val="1000"/>
+                <a:spcPts val="700"/>
               </a:spcAft>
               <a:defRPr sz="950">
                 <a:solidFill>
@@ -5827,36 +7817,7 @@
               </a:defRPr>
             </a:pPr>
             <a:r>
-              <a:t>I can immediately test whether a steering vector discovered in base GPT-2 transfers to a fine-tuned checkpoint.</a:t>
-            </a:r>
-          </a:p>
-          <a:p>
-            <a:pPr>
-              <a:defRPr sz="1100" b="1">
-                <a:solidFill>
-                  <a:srgbClr val="047857"/>
-                </a:solidFill>
-                <a:latin typeface="Arial"/>
-              </a:defRPr>
-            </a:pPr>
-            <a:r>
-              <a:t>Why It Matters</a:t>
-            </a:r>
-          </a:p>
-          <a:p>
-            <a:pPr>
-              <a:spcAft>
-                <a:spcPts val="1000"/>
-              </a:spcAft>
-              <a:defRPr sz="950">
-                <a:solidFill>
-                  <a:srgbClr val="4B5563"/>
-                </a:solidFill>
-                <a:latin typeface="Arial"/>
-              </a:defRPr>
-            </a:pPr>
-            <a:r>
-              <a:t>Enables rapid hypothesis verification across model versions and checkpoints.</a:t>
+              <a:t>Side-by-side comparison makes causal behavioral changes immediately obvious.</a:t>
             </a:r>
           </a:p>
         </p:txBody>
@@ -5869,8 +7830,8 @@
         </p:nvSpPr>
         <p:spPr>
           <a:xfrm>
-            <a:off x="5029200" y="1325880"/>
-            <a:ext cx="6430975" cy="5074920"/>
+            <a:off x="5010912" y="1298448"/>
+            <a:ext cx="6446520" cy="5120640"/>
           </a:xfrm>
           <a:prstGeom prst="roundRect">
             <a:avLst/>
@@ -5908,7 +7869,7 @@
       </p:sp>
       <p:pic>
         <p:nvPicPr>
-          <p:cNvPr id="7" name="Picture 6" descr="slide5_cross_model_switch.png"/>
+          <p:cNvPr id="7" name="Picture 6" descr="step5_click_apply_steer.png"/>
           <p:cNvPicPr>
             <a:picLocks noChangeAspect="1"/>
           </p:cNvPicPr>
@@ -5922,8 +7883,8 @@
         </p:blipFill>
         <p:spPr>
           <a:xfrm>
-            <a:off x="5138928" y="1435608"/>
-            <a:ext cx="6208776" cy="4855464"/>
+            <a:off x="5120640" y="1408176"/>
+            <a:ext cx="6227064" cy="4901184"/>
           </a:xfrm>
           <a:prstGeom prst="rect">
             <a:avLst/>
@@ -6002,7 +7963,7 @@
         <p:spPr>
           <a:xfrm>
             <a:off x="731520" y="365760"/>
-            <a:ext cx="5486400" cy="320040"/>
+            <a:ext cx="6858000" cy="292608"/>
           </a:xfrm>
           <a:prstGeom prst="rect">
             <a:avLst/>
@@ -6018,13 +7979,13 @@
             <a:pPr>
               <a:defRPr sz="1000" b="1">
                 <a:solidFill>
-                  <a:srgbClr val="047857"/>
-                </a:solidFill>
-                <a:latin typeface="Arial"/>
-              </a:defRPr>
-            </a:pPr>
-            <a:r>
-              <a:t>AUTOEXPLAIN STUDIO · USER JOURNEY</a:t>
+                  <a:srgbClr val="EF4444"/>
+                </a:solidFill>
+                <a:latin typeface="Arial"/>
+              </a:defRPr>
+            </a:pPr>
+            <a:r>
+              <a:t>STEP 6 OF 10 · RED CIRCLE: PRESET PILL '🚫 SUPPRESS PARIS'</a:t>
             </a:r>
           </a:p>
         </p:txBody>
@@ -6052,7 +8013,7 @@
           <a:lstStyle/>
           <a:p>
             <a:pPr>
-              <a:defRPr sz="2200" b="1">
+              <a:defRPr sz="2100" b="1">
                 <a:solidFill>
                   <a:srgbClr val="111815"/>
                 </a:solidFill>
@@ -6060,7 +8021,7 @@
               </a:defRPr>
             </a:pPr>
             <a:r>
-              <a:t>Verification &amp; Implementation Summary</a:t>
+              <a:t>Step 6: Negative Steering &amp; Thought Suppression</a:t>
             </a:r>
           </a:p>
         </p:txBody>
@@ -6073,8 +8034,8 @@
         </p:nvSpPr>
         <p:spPr>
           <a:xfrm>
-            <a:off x="731520" y="1371600"/>
-            <a:ext cx="5257800" cy="2240280"/>
+            <a:off x="731520" y="1298448"/>
+            <a:ext cx="4114800" cy="5120640"/>
           </a:xfrm>
           <a:prstGeom prst="roundRect">
             <a:avLst/>
@@ -6103,11 +8064,27 @@
           </a:fontRef>
         </p:style>
         <p:txBody>
-          <a:bodyPr rtlCol="0" anchor="ctr" wrap="square" lIns="274320" rIns="274320" tIns="182880"/>
+          <a:bodyPr rtlCol="0" anchor="ctr" wrap="square" lIns="256032" rIns="256032" tIns="228600"/>
           <a:lstStyle/>
           <a:p>
             <a:pPr algn="ctr">
-              <a:defRPr sz="1200" b="1">
+              <a:spcAft>
+                <a:spcPts val="800"/>
+              </a:spcAft>
+              <a:defRPr sz="1100" b="1">
+                <a:solidFill>
+                  <a:srgbClr val="EF4444"/>
+                </a:solidFill>
+                <a:latin typeface="Arial"/>
+              </a:defRPr>
+            </a:pPr>
+            <a:r>
+              <a:t>🔴 RED CIRCLE CLICK: Preset Pill '🚫 Suppress Paris'</a:t>
+            </a:r>
+          </a:p>
+          <a:p>
+            <a:pPr>
+              <a:defRPr sz="1050" b="1">
                 <a:solidFill>
                   <a:srgbClr val="047857"/>
                 </a:solidFill>
@@ -6115,27 +8092,14 @@
               </a:defRPr>
             </a:pPr>
             <a:r>
-              <a:t>Acceptance Test Suite</a:t>
+              <a:t>My Action as User</a:t>
             </a:r>
           </a:p>
           <a:p>
             <a:pPr>
               <a:spcAft>
-                <a:spcPts val="400"/>
+                <a:spcPts val="700"/>
               </a:spcAft>
-              <a:defRPr sz="1000" b="1">
-                <a:solidFill>
-                  <a:srgbClr val="111815"/>
-                </a:solidFill>
-                <a:latin typeface="Arial"/>
-              </a:defRPr>
-            </a:pPr>
-            <a:r>
-              <a:t>tests/test_web_ux.py</a:t>
-            </a:r>
-          </a:p>
-          <a:p>
-            <a:pPr>
               <a:defRPr sz="950">
                 <a:solidFill>
                   <a:srgbClr val="4B5563"/>
@@ -6144,23 +8108,94 @@
               </a:defRPr>
             </a:pPr>
             <a:r>
-              <a:t>All 4 User Stories verified under pytest with zero GPU dependencies required:</a:t>
-            </a:r>
-            <a:br/>
-            <a:r>
-              <a:t>• Story 1: Zero-setup pre-loaded arrival</a:t>
-            </a:r>
-            <a:br/>
-            <a:r>
-              <a:t>• Story 2: Plain-English concept readout</a:t>
-            </a:r>
-            <a:br/>
-            <a:r>
-              <a:t>• Story 3: Causal steering &amp; side-by-side diff</a:t>
-            </a:r>
-            <a:br/>
-            <a:r>
-              <a:t>• Story 4: Cross-model preset persistence</a:t>
+              <a:t>I click the preset pill '🚫 Suppress Paris' to inhibit the active certainty node.</a:t>
+            </a:r>
+          </a:p>
+          <a:p>
+            <a:pPr>
+              <a:defRPr sz="1050" b="1">
+                <a:solidFill>
+                  <a:srgbClr val="047857"/>
+                </a:solidFill>
+                <a:latin typeface="Arial"/>
+              </a:defRPr>
+            </a:pPr>
+            <a:r>
+              <a:t>What I See</a:t>
+            </a:r>
+          </a:p>
+          <a:p>
+            <a:pPr>
+              <a:spcAft>
+                <a:spcPts val="700"/>
+              </a:spcAft>
+              <a:defRPr sz="950">
+                <a:solidFill>
+                  <a:srgbClr val="4B5563"/>
+                </a:solidFill>
+                <a:latin typeface="Arial"/>
+              </a:defRPr>
+            </a:pPr>
+            <a:r>
+              <a:t>Steered output shifts to descriptive fallback: 'The capital of France is a historic European city renowned for culture and architecture.'</a:t>
+            </a:r>
+          </a:p>
+          <a:p>
+            <a:pPr>
+              <a:defRPr sz="1050" b="1">
+                <a:solidFill>
+                  <a:srgbClr val="047857"/>
+                </a:solidFill>
+                <a:latin typeface="Arial"/>
+              </a:defRPr>
+            </a:pPr>
+            <a:r>
+              <a:t>Model Behavior</a:t>
+            </a:r>
+          </a:p>
+          <a:p>
+            <a:pPr>
+              <a:spcAft>
+                <a:spcPts val="700"/>
+              </a:spcAft>
+              <a:defRPr sz="950">
+                <a:solidFill>
+                  <a:srgbClr val="4B5563"/>
+                </a:solidFill>
+                <a:latin typeface="Arial"/>
+              </a:defRPr>
+            </a:pPr>
+            <a:r>
+              <a:t>The model eliminates the specific token 'Paris' while maintaining grammatical coherence.</a:t>
+            </a:r>
+          </a:p>
+          <a:p>
+            <a:pPr>
+              <a:defRPr sz="1050" b="1">
+                <a:solidFill>
+                  <a:srgbClr val="047857"/>
+                </a:solidFill>
+                <a:latin typeface="Arial"/>
+              </a:defRPr>
+            </a:pPr>
+            <a:r>
+              <a:t>Why It Matters</a:t>
+            </a:r>
+          </a:p>
+          <a:p>
+            <a:pPr>
+              <a:spcAft>
+                <a:spcPts val="700"/>
+              </a:spcAft>
+              <a:defRPr sz="950">
+                <a:solidFill>
+                  <a:srgbClr val="4B5563"/>
+                </a:solidFill>
+                <a:latin typeface="Arial"/>
+              </a:defRPr>
+            </a:pPr>
+            <a:r>
+              <a:t>Verifies model behavior under factual suppression without fine-tuning or weight retraining.</a:t>
             </a:r>
           </a:p>
         </p:txBody>
@@ -6173,8 +8208,8 @@
         </p:nvSpPr>
         <p:spPr>
           <a:xfrm>
-            <a:off x="6172200" y="1371600"/>
-            <a:ext cx="5257800" cy="2240280"/>
+            <a:off x="5010912" y="1298448"/>
+            <a:ext cx="6446520" cy="5120640"/>
           </a:xfrm>
           <a:prstGeom prst="roundRect">
             <a:avLst/>
@@ -6203,78 +8238,182 @@
           </a:fontRef>
         </p:style>
         <p:txBody>
-          <a:bodyPr rtlCol="0" anchor="ctr" wrap="square" lIns="274320" rIns="274320" tIns="182880"/>
-          <a:lstStyle/>
-          <a:p>
-            <a:pPr algn="ctr">
-              <a:defRPr sz="1200" b="1">
-                <a:solidFill>
-                  <a:srgbClr val="047857"/>
-                </a:solidFill>
-                <a:latin typeface="Arial"/>
-              </a:defRPr>
-            </a:pPr>
-            <a:r>
-              <a:t>Full Repository Health</a:t>
-            </a:r>
-          </a:p>
-          <a:p>
-            <a:pPr>
-              <a:spcAft>
-                <a:spcPts val="400"/>
-              </a:spcAft>
-              <a:defRPr sz="1000" b="1">
-                <a:solidFill>
-                  <a:srgbClr val="111815"/>
-                </a:solidFill>
-                <a:latin typeface="Arial"/>
-              </a:defRPr>
-            </a:pPr>
-            <a:r>
-              <a:t>27 / 27 Tests Passing</a:t>
-            </a:r>
-          </a:p>
-          <a:p>
-            <a:pPr>
-              <a:defRPr sz="950">
-                <a:solidFill>
-                  <a:srgbClr val="4B5563"/>
-                </a:solidFill>
-                <a:latin typeface="Arial"/>
-              </a:defRPr>
-            </a:pPr>
-            <a:r>
-              <a:t>Complete test coverage across all subsystems:</a:t>
-            </a:r>
-            <a:br/>
-            <a:r>
-              <a:t>• test_web_ux.py: 4/4 passing</a:t>
-            </a:r>
-            <a:br/>
-            <a:r>
-              <a:t>• test_harness.py: 11/11 passing (P0/P1/P2 fixes)</a:t>
-            </a:r>
-            <a:br/>
-            <a:r>
-              <a:t>• test_nla.py: 8/8 passing</a:t>
-            </a:r>
-            <a:br/>
-            <a:r>
-              <a:t>• test_core.py: 4/4 passing</a:t>
-            </a:r>
-          </a:p>
-        </p:txBody>
-      </p:sp>
-      <p:sp>
-        <p:nvSpPr>
-          <p:cNvPr id="7" name="Rounded Rectangle 6"/>
+          <a:bodyPr rtlCol="0" anchor="ctr"/>
+          <a:lstStyle/>
+          <a:p>
+            <a:pPr algn="ctr"/>
+          </a:p>
+        </p:txBody>
+      </p:sp>
+      <p:pic>
+        <p:nvPicPr>
+          <p:cNvPr id="7" name="Picture 6" descr="step6_click_suppress_paris.png"/>
+          <p:cNvPicPr>
+            <a:picLocks noChangeAspect="1"/>
+          </p:cNvPicPr>
+          <p:nvPr/>
+        </p:nvPicPr>
+        <p:blipFill>
+          <a:blip r:embed="rId2"/>
+          <a:stretch>
+            <a:fillRect/>
+          </a:stretch>
+        </p:blipFill>
+        <p:spPr>
+          <a:xfrm>
+            <a:off x="5120640" y="1408176"/>
+            <a:ext cx="6227064" cy="4901184"/>
+          </a:xfrm>
+          <a:prstGeom prst="rect">
+            <a:avLst/>
+          </a:prstGeom>
+        </p:spPr>
+      </p:pic>
+    </p:spTree>
+  </p:cSld>
+  <p:clrMapOvr>
+    <a:masterClrMapping/>
+  </p:clrMapOvr>
+</p:sld>
+</file>
+
+<file path=ppt/slides/slide9.xml><?xml version="1.0" encoding="utf-8"?>
+<p:sld xmlns:a="http://schemas.openxmlformats.org/drawingml/2006/main" xmlns:p="http://schemas.openxmlformats.org/presentationml/2006/main" xmlns:r="http://schemas.openxmlformats.org/officeDocument/2006/relationships">
+  <p:cSld>
+    <p:spTree>
+      <p:nvGrpSpPr>
+        <p:cNvPr id="1" name=""/>
+        <p:cNvGrpSpPr/>
+        <p:nvPr/>
+      </p:nvGrpSpPr>
+      <p:grpSpPr/>
+      <p:sp>
+        <p:nvSpPr>
+          <p:cNvPr id="2" name="Rectangle 1"/>
           <p:cNvSpPr/>
           <p:nvPr/>
         </p:nvSpPr>
         <p:spPr>
           <a:xfrm>
-            <a:off x="731520" y="3840480"/>
-            <a:ext cx="5257800" cy="2240280"/>
+            <a:off x="0" y="0"/>
+            <a:ext cx="12191695" cy="6858000"/>
+          </a:xfrm>
+          <a:prstGeom prst="rect">
+            <a:avLst/>
+          </a:prstGeom>
+          <a:solidFill>
+            <a:srgbClr val="F7FAF8"/>
+          </a:solidFill>
+          <a:ln>
+            <a:solidFill>
+              <a:srgbClr val="F7FAF8"/>
+            </a:solidFill>
+          </a:ln>
+        </p:spPr>
+        <p:style>
+          <a:lnRef idx="1">
+            <a:schemeClr val="accent1"/>
+          </a:lnRef>
+          <a:fillRef idx="3">
+            <a:schemeClr val="accent1"/>
+          </a:fillRef>
+          <a:effectRef idx="2">
+            <a:schemeClr val="accent1"/>
+          </a:effectRef>
+          <a:fontRef idx="minor">
+            <a:schemeClr val="lt1"/>
+          </a:fontRef>
+        </p:style>
+        <p:txBody>
+          <a:bodyPr rtlCol="0" anchor="ctr"/>
+          <a:lstStyle/>
+          <a:p>
+            <a:pPr algn="ctr"/>
+          </a:p>
+        </p:txBody>
+      </p:sp>
+      <p:sp>
+        <p:nvSpPr>
+          <p:cNvPr id="3" name="TextBox 2"/>
+          <p:cNvSpPr txBox="1"/>
+          <p:nvPr/>
+        </p:nvSpPr>
+        <p:spPr>
+          <a:xfrm>
+            <a:off x="731520" y="365760"/>
+            <a:ext cx="6858000" cy="292608"/>
+          </a:xfrm>
+          <a:prstGeom prst="rect">
+            <a:avLst/>
+          </a:prstGeom>
+          <a:noFill/>
+        </p:spPr>
+        <p:txBody>
+          <a:bodyPr wrap="square" lIns="0" tIns="0" rIns="0" bIns="0">
+            <a:spAutoFit/>
+          </a:bodyPr>
+          <a:lstStyle/>
+          <a:p>
+            <a:pPr>
+              <a:defRPr sz="1000" b="1">
+                <a:solidFill>
+                  <a:srgbClr val="EF4444"/>
+                </a:solidFill>
+                <a:latin typeface="Arial"/>
+              </a:defRPr>
+            </a:pPr>
+            <a:r>
+              <a:t>STEP 7 OF 10 · RED CIRCLE: BUTTON [ SAVE STEER ] IN CARD 2</a:t>
+            </a:r>
+          </a:p>
+        </p:txBody>
+      </p:sp>
+      <p:sp>
+        <p:nvSpPr>
+          <p:cNvPr id="4" name="TextBox 3"/>
+          <p:cNvSpPr txBox="1"/>
+          <p:nvPr/>
+        </p:nvSpPr>
+        <p:spPr>
+          <a:xfrm>
+            <a:off x="731520" y="658368"/>
+            <a:ext cx="10515600" cy="548640"/>
+          </a:xfrm>
+          <a:prstGeom prst="rect">
+            <a:avLst/>
+          </a:prstGeom>
+          <a:noFill/>
+        </p:spPr>
+        <p:txBody>
+          <a:bodyPr wrap="square" lIns="0" tIns="0" rIns="0" bIns="0">
+            <a:spAutoFit/>
+          </a:bodyPr>
+          <a:lstStyle/>
+          <a:p>
+            <a:pPr>
+              <a:defRPr sz="2100" b="1">
+                <a:solidFill>
+                  <a:srgbClr val="111815"/>
+                </a:solidFill>
+                <a:latin typeface="Arial"/>
+              </a:defRPr>
+            </a:pPr>
+            <a:r>
+              <a:t>Step 7: Saving Custom Steer Presets</a:t>
+            </a:r>
+          </a:p>
+        </p:txBody>
+      </p:sp>
+      <p:sp>
+        <p:nvSpPr>
+          <p:cNvPr id="5" name="Rounded Rectangle 4"/>
+          <p:cNvSpPr/>
+          <p:nvPr/>
+        </p:nvSpPr>
+        <p:spPr>
+          <a:xfrm>
+            <a:off x="731520" y="1298448"/>
+            <a:ext cx="4114800" cy="5120640"/>
           </a:xfrm>
           <a:prstGeom prst="roundRect">
             <a:avLst/>
@@ -6303,11 +8442,27 @@
           </a:fontRef>
         </p:style>
         <p:txBody>
-          <a:bodyPr rtlCol="0" anchor="ctr" wrap="square" lIns="274320" rIns="274320" tIns="182880"/>
+          <a:bodyPr rtlCol="0" anchor="ctr" wrap="square" lIns="256032" rIns="256032" tIns="228600"/>
           <a:lstStyle/>
           <a:p>
             <a:pPr algn="ctr">
-              <a:defRPr sz="1200" b="1">
+              <a:spcAft>
+                <a:spcPts val="800"/>
+              </a:spcAft>
+              <a:defRPr sz="1100" b="1">
+                <a:solidFill>
+                  <a:srgbClr val="EF4444"/>
+                </a:solidFill>
+                <a:latin typeface="Arial"/>
+              </a:defRPr>
+            </a:pPr>
+            <a:r>
+              <a:t>🔴 RED CIRCLE CLICK: Button [ Save Steer ] in Card 2</a:t>
+            </a:r>
+          </a:p>
+          <a:p>
+            <a:pPr>
+              <a:defRPr sz="1050" b="1">
                 <a:solidFill>
                   <a:srgbClr val="047857"/>
                 </a:solidFill>
@@ -6315,27 +8470,14 @@
               </a:defRPr>
             </a:pPr>
             <a:r>
-              <a:t>Architectural Alignment</a:t>
+              <a:t>My Action as User</a:t>
             </a:r>
           </a:p>
           <a:p>
             <a:pPr>
               <a:spcAft>
-                <a:spcPts val="400"/>
+                <a:spcPts val="700"/>
               </a:spcAft>
-              <a:defRPr sz="1000" b="1">
-                <a:solidFill>
-                  <a:srgbClr val="111815"/>
-                </a:solidFill>
-                <a:latin typeface="Arial"/>
-              </a:defRPr>
-            </a:pPr>
-            <a:r>
-              <a:t>AutoExplain Harness &amp; Methods</a:t>
-            </a:r>
-          </a:p>
-          <a:p>
-            <a:pPr>
               <a:defRPr sz="950">
                 <a:solidFill>
                   <a:srgbClr val="4B5563"/>
@@ -6344,33 +8486,108 @@
               </a:defRPr>
             </a:pPr>
             <a:r>
-              <a:t>FastAPI web endpoints cleanly map to core harness actions:</a:t>
-            </a:r>
-            <a:br/>
-            <a:r>
-              <a:t>• open_model / inspect → Top Header &amp; Upload</a:t>
-            </a:r>
-            <a:br/>
-            <a:r>
-              <a:t>• run / observe → Card 1 (Interpret)</a:t>
-            </a:r>
-            <a:br/>
-            <a:r>
-              <a:t>• intervene / reset / record → Card 2 (Steer)</a:t>
-            </a:r>
-          </a:p>
-        </p:txBody>
-      </p:sp>
-      <p:sp>
-        <p:nvSpPr>
-          <p:cNvPr id="8" name="Rounded Rectangle 7"/>
+              <a:t>I configure a new steering concept and click '[ Save Steer ]'.</a:t>
+            </a:r>
+          </a:p>
+          <a:p>
+            <a:pPr>
+              <a:defRPr sz="1050" b="1">
+                <a:solidFill>
+                  <a:srgbClr val="047857"/>
+                </a:solidFill>
+                <a:latin typeface="Arial"/>
+              </a:defRPr>
+            </a:pPr>
+            <a:r>
+              <a:t>What I See</a:t>
+            </a:r>
+          </a:p>
+          <a:p>
+            <a:pPr>
+              <a:spcAft>
+                <a:spcPts val="700"/>
+              </a:spcAft>
+              <a:defRPr sz="950">
+                <a:solidFill>
+                  <a:srgbClr val="4B5563"/>
+                </a:solidFill>
+                <a:latin typeface="Arial"/>
+              </a:defRPr>
+            </a:pPr>
+            <a:r>
+              <a:t>A prompt requests a preset name, and the new preset appears as a clickable pill with a delete button (×).</a:t>
+            </a:r>
+          </a:p>
+          <a:p>
+            <a:pPr>
+              <a:defRPr sz="1050" b="1">
+                <a:solidFill>
+                  <a:srgbClr val="047857"/>
+                </a:solidFill>
+                <a:latin typeface="Arial"/>
+              </a:defRPr>
+            </a:pPr>
+            <a:r>
+              <a:t>Preservation</a:t>
+            </a:r>
+          </a:p>
+          <a:p>
+            <a:pPr>
+              <a:spcAft>
+                <a:spcPts val="700"/>
+              </a:spcAft>
+              <a:defRPr sz="950">
+                <a:solidFill>
+                  <a:srgbClr val="4B5563"/>
+                </a:solidFill>
+                <a:latin typeface="Arial"/>
+              </a:defRPr>
+            </a:pPr>
+            <a:r>
+              <a:t>Stored directly in Card 2's presets row for immediate reuse.</a:t>
+            </a:r>
+          </a:p>
+          <a:p>
+            <a:pPr>
+              <a:defRPr sz="1050" b="1">
+                <a:solidFill>
+                  <a:srgbClr val="047857"/>
+                </a:solidFill>
+                <a:latin typeface="Arial"/>
+              </a:defRPr>
+            </a:pPr>
+            <a:r>
+              <a:t>Why It Matters</a:t>
+            </a:r>
+          </a:p>
+          <a:p>
+            <a:pPr>
+              <a:spcAft>
+                <a:spcPts val="700"/>
+              </a:spcAft>
+              <a:defRPr sz="950">
+                <a:solidFill>
+                  <a:srgbClr val="4B5563"/>
+                </a:solidFill>
+                <a:latin typeface="Arial"/>
+              </a:defRPr>
+            </a:pPr>
+            <a:r>
+              <a:t>Allows researchers to curate a personal library of validated concept steering vectors.</a:t>
+            </a:r>
+          </a:p>
+        </p:txBody>
+      </p:sp>
+      <p:sp>
+        <p:nvSpPr>
+          <p:cNvPr id="6" name="Rounded Rectangle 5"/>
           <p:cNvSpPr/>
           <p:nvPr/>
         </p:nvSpPr>
         <p:spPr>
           <a:xfrm>
-            <a:off x="6172200" y="3840480"/>
-            <a:ext cx="5257800" cy="2240280"/>
+            <a:off x="5010912" y="1298448"/>
+            <a:ext cx="6446520" cy="5120640"/>
           </a:xfrm>
           <a:prstGeom prst="roundRect">
             <a:avLst/>
@@ -6399,68 +8616,37 @@
           </a:fontRef>
         </p:style>
         <p:txBody>
-          <a:bodyPr rtlCol="0" anchor="ctr" wrap="square" lIns="274320" rIns="274320" tIns="182880"/>
-          <a:lstStyle/>
-          <a:p>
-            <a:pPr algn="ctr">
-              <a:defRPr sz="1200" b="1">
-                <a:solidFill>
-                  <a:srgbClr val="047857"/>
-                </a:solidFill>
-                <a:latin typeface="Arial"/>
-              </a:defRPr>
-            </a:pPr>
-            <a:r>
-              <a:t>Roadmap Next Steps</a:t>
-            </a:r>
-          </a:p>
-          <a:p>
-            <a:pPr>
-              <a:spcAft>
-                <a:spcPts val="400"/>
-              </a:spcAft>
-              <a:defRPr sz="1000" b="1">
-                <a:solidFill>
-                  <a:srgbClr val="111815"/>
-                </a:solidFill>
-                <a:latin typeface="Arial"/>
-              </a:defRPr>
-            </a:pPr>
-            <a:r>
-              <a:t>Feature Milestones Ahead</a:t>
-            </a:r>
-          </a:p>
-          <a:p>
-            <a:pPr>
-              <a:defRPr sz="950">
-                <a:solidFill>
-                  <a:srgbClr val="4B5563"/>
-                </a:solidFill>
-                <a:latin typeface="Arial"/>
-              </a:defRPr>
-            </a:pPr>
-            <a:r>
-              <a:t>Future interpretability methods ready for harness wiring:</a:t>
-            </a:r>
-            <a:br/>
-            <a:r>
-              <a:t>• F1: Sparse Autoencoders (SAE)</a:t>
-            </a:r>
-            <a:br/>
-            <a:r>
-              <a:t>• F2: Jacobian Lens (J-Space)</a:t>
-            </a:r>
-            <a:br/>
-            <a:r>
-              <a:t>• F3: Autonomous Agentic Investigator</a:t>
-            </a:r>
-            <a:br/>
-            <a:r>
-              <a:t>• F5: Block-Sparse Featurizers</a:t>
-            </a:r>
-          </a:p>
-        </p:txBody>
-      </p:sp>
+          <a:bodyPr rtlCol="0" anchor="ctr"/>
+          <a:lstStyle/>
+          <a:p>
+            <a:pPr algn="ctr"/>
+          </a:p>
+        </p:txBody>
+      </p:sp>
+      <p:pic>
+        <p:nvPicPr>
+          <p:cNvPr id="7" name="Picture 6" descr="step7_click_save_steer.png"/>
+          <p:cNvPicPr>
+            <a:picLocks noChangeAspect="1"/>
+          </p:cNvPicPr>
+          <p:nvPr/>
+        </p:nvPicPr>
+        <p:blipFill>
+          <a:blip r:embed="rId2"/>
+          <a:stretch>
+            <a:fillRect/>
+          </a:stretch>
+        </p:blipFill>
+        <p:spPr>
+          <a:xfrm>
+            <a:off x="5120640" y="1408176"/>
+            <a:ext cx="6227064" cy="4901184"/>
+          </a:xfrm>
+          <a:prstGeom prst="rect">
+            <a:avLst/>
+          </a:prstGeom>
+        </p:spPr>
+      </p:pic>
     </p:spTree>
   </p:cSld>
   <p:clrMapOvr>

</xml_diff>